<commit_message>
Add browser app UI for ea-slide-builder
Replaces CLI-only workflow with a local Flask web app (app/server.py)
that opens automatically at localhost:5000. Supports drag-and-drop file
upload, inline contract form with dynamic bundle/license tables, and
one-click download of the generated PPTX and insights report.

https://claude.ai/code/session_01AoMkzwC6zY1HEwhzq88oiT
</commit_message>
<xml_diff>
--- a/ea-slide-builder/output/EA-123456_Acme_Corporation_summary.pptx
+++ b/ea-slide-builder/output/EA-123456_Acme_Corporation_summary.pptx
@@ -3404,7 +3404,7 @@
         </p:nvGraphicFramePr>
         <p:xfrm>
           <a:off x="228600" y="1578600"/>
-          <a:ext cx="2819399" cy="637200"/>
+          <a:ext cx="2819399" cy="424800"/>
         </p:xfrm>
         <a:graphic>
           <a:graphicData uri="http://schemas.openxmlformats.org/drawingml/2006/table">
@@ -3478,7 +3478,7 @@
                         </a:defRPr>
                       </a:pPr>
                       <a:r>
-                        <a:t>Design Suite Bundle</a:t>
+                        <a:t>Design Suite</a:t>
                       </a:r>
                     </a:p>
                   </a:txBody>
@@ -3508,54 +3508,6 @@
                   <a:tcPr>
                     <a:solidFill>
                       <a:srgbClr val="FFFFFF"/>
-                    </a:solidFill>
-                  </a:tcPr>
-                </a:tc>
-              </a:tr>
-              <a:tr h="212400">
-                <a:tc>
-                  <a:txBody>
-                    <a:bodyPr/>
-                    <a:lstStyle/>
-                    <a:p>
-                      <a:pPr>
-                        <a:defRPr sz="800" b="0">
-                          <a:solidFill>
-                            <a:srgbClr val="000000"/>
-                          </a:solidFill>
-                        </a:defRPr>
-                      </a:pPr>
-                      <a:r>
-                        <a:t>Simulation Bundle</a:t>
-                      </a:r>
-                    </a:p>
-                  </a:txBody>
-                  <a:tcPr>
-                    <a:solidFill>
-                      <a:srgbClr val="F2F2F2"/>
-                    </a:solidFill>
-                  </a:tcPr>
-                </a:tc>
-                <a:tc>
-                  <a:txBody>
-                    <a:bodyPr/>
-                    <a:lstStyle/>
-                    <a:p>
-                      <a:pPr>
-                        <a:defRPr sz="800" b="0">
-                          <a:solidFill>
-                            <a:srgbClr val="000000"/>
-                          </a:solidFill>
-                        </a:defRPr>
-                      </a:pPr>
-                      <a:r>
-                        <a:t>Suite</a:t>
-                      </a:r>
-                    </a:p>
-                  </a:txBody>
-                  <a:tcPr>
-                    <a:solidFill>
-                      <a:srgbClr val="F2F2F2"/>
                     </a:solidFill>
                   </a:tcPr>
                 </a:tc>
@@ -3572,7 +3524,7 @@
         </p:nvSpPr>
         <p:spPr>
           <a:xfrm>
-            <a:off x="228600" y="2315800"/>
+            <a:off x="228600" y="2103400"/>
             <a:ext cx="2819400" cy="207000"/>
           </a:xfrm>
           <a:prstGeom prst="rect">
@@ -3609,8 +3561,8 @@
           <p:nvPr/>
         </p:nvGraphicFramePr>
         <p:xfrm>
-          <a:off x="228600" y="2522800"/>
-          <a:ext cx="2819400" cy="1062000"/>
+          <a:off x="228600" y="2310400"/>
+          <a:ext cx="2819400" cy="637200"/>
         </p:xfrm>
         <a:graphic>
           <a:graphicData uri="http://schemas.openxmlformats.org/drawingml/2006/table">
@@ -3803,148 +3755,6 @@
                       </a:pPr>
                       <a:r>
                         <a:t>Revit</a:t>
-                      </a:r>
-                    </a:p>
-                  </a:txBody>
-                  <a:tcPr>
-                    <a:solidFill>
-                      <a:srgbClr val="F2F2F2"/>
-                    </a:solidFill>
-                  </a:tcPr>
-                </a:tc>
-                <a:tc>
-                  <a:txBody>
-                    <a:bodyPr/>
-                    <a:lstStyle/>
-                    <a:p>
-                      <a:pPr>
-                        <a:defRPr sz="800" b="0">
-                          <a:solidFill>
-                            <a:srgbClr val="000000"/>
-                          </a:solidFill>
-                        </a:defRPr>
-                      </a:pPr>
-                      <a:r>
-                        <a:t>Named User</a:t>
-                      </a:r>
-                    </a:p>
-                  </a:txBody>
-                  <a:tcPr>
-                    <a:solidFill>
-                      <a:srgbClr val="F2F2F2"/>
-                    </a:solidFill>
-                  </a:tcPr>
-                </a:tc>
-              </a:tr>
-              <a:tr h="212400">
-                <a:tc>
-                  <a:txBody>
-                    <a:bodyPr/>
-                    <a:lstStyle/>
-                    <a:p>
-                      <a:pPr>
-                        <a:defRPr sz="800" b="0">
-                          <a:solidFill>
-                            <a:srgbClr val="000000"/>
-                          </a:solidFill>
-                        </a:defRPr>
-                      </a:pPr>
-                      <a:r>
-                        <a:t>100</a:t>
-                      </a:r>
-                    </a:p>
-                  </a:txBody>
-                  <a:tcPr>
-                    <a:solidFill>
-                      <a:srgbClr val="FFFFFF"/>
-                    </a:solidFill>
-                  </a:tcPr>
-                </a:tc>
-                <a:tc>
-                  <a:txBody>
-                    <a:bodyPr/>
-                    <a:lstStyle/>
-                    <a:p>
-                      <a:pPr>
-                        <a:defRPr sz="800" b="0">
-                          <a:solidFill>
-                            <a:srgbClr val="000000"/>
-                          </a:solidFill>
-                        </a:defRPr>
-                      </a:pPr>
-                      <a:r>
-                        <a:t>Inventor</a:t>
-                      </a:r>
-                    </a:p>
-                  </a:txBody>
-                  <a:tcPr>
-                    <a:solidFill>
-                      <a:srgbClr val="FFFFFF"/>
-                    </a:solidFill>
-                  </a:tcPr>
-                </a:tc>
-                <a:tc>
-                  <a:txBody>
-                    <a:bodyPr/>
-                    <a:lstStyle/>
-                    <a:p>
-                      <a:pPr>
-                        <a:defRPr sz="800" b="0">
-                          <a:solidFill>
-                            <a:srgbClr val="000000"/>
-                          </a:solidFill>
-                        </a:defRPr>
-                      </a:pPr>
-                      <a:r>
-                        <a:t>Named User</a:t>
-                      </a:r>
-                    </a:p>
-                  </a:txBody>
-                  <a:tcPr>
-                    <a:solidFill>
-                      <a:srgbClr val="FFFFFF"/>
-                    </a:solidFill>
-                  </a:tcPr>
-                </a:tc>
-              </a:tr>
-              <a:tr h="212400">
-                <a:tc>
-                  <a:txBody>
-                    <a:bodyPr/>
-                    <a:lstStyle/>
-                    <a:p>
-                      <a:pPr>
-                        <a:defRPr sz="800" b="0">
-                          <a:solidFill>
-                            <a:srgbClr val="000000"/>
-                          </a:solidFill>
-                        </a:defRPr>
-                      </a:pPr>
-                      <a:r>
-                        <a:t>50</a:t>
-                      </a:r>
-                    </a:p>
-                  </a:txBody>
-                  <a:tcPr>
-                    <a:solidFill>
-                      <a:srgbClr val="F2F2F2"/>
-                    </a:solidFill>
-                  </a:tcPr>
-                </a:tc>
-                <a:tc>
-                  <a:txBody>
-                    <a:bodyPr/>
-                    <a:lstStyle/>
-                    <a:p>
-                      <a:pPr>
-                        <a:defRPr sz="800" b="0">
-                          <a:solidFill>
-                            <a:srgbClr val="000000"/>
-                          </a:solidFill>
-                        </a:defRPr>
-                      </a:pPr>
-                      <a:r>
-                        <a:t>Navisworks</a:t>
                       </a:r>
                     </a:p>
                   </a:txBody>

</xml_diff>

<commit_message>
Fix column detection for real Tableau/BI exports; add top versions option
- Fix count_col detection: exclude already-identified structural columns
  before searching, preventing "count" matching inside "ip_country"
- Add "values" candidate to handle "Measure Values" column names
- Add top_versions param: limits version rows shown per product (like top_cities)
- Cities: filter to product_name="*" rows (deduplicated aggregates) to avoid
  double-counting machines that use multiple products
- Verified against real RTX_Usage_Data.xlsx: all three tabs detected correctly

https://claude.ai/code/session_01AoMkzwC6zY1HEwhzq88oiT
</commit_message>
<xml_diff>
--- a/ea-slide-builder/output/EA-123456_Acme_Corporation_summary.pptx
+++ b/ea-slide-builder/output/EA-123456_Acme_Corporation_summary.pptx
@@ -142,65 +142,143 @@
           </c:marker>
           <c:cat>
             <c:strRef>
-              <c:f>Sheet1!$A$2:$A$9</c:f>
+              <c:f>Sheet1!$A$2:$A$22</c:f>
               <c:strCache>
-                <c:ptCount val="8"/>
+                <c:ptCount val="21"/>
                 <c:pt idx="0">
+                  <c:v>2021 Q1</c:v>
+                </c:pt>
+                <c:pt idx="1">
+                  <c:v>2021 Q2</c:v>
+                </c:pt>
+                <c:pt idx="2">
+                  <c:v>2021 Q3</c:v>
+                </c:pt>
+                <c:pt idx="3">
+                  <c:v>2021 Q4</c:v>
+                </c:pt>
+                <c:pt idx="4">
+                  <c:v>2022 Q1</c:v>
+                </c:pt>
+                <c:pt idx="5">
+                  <c:v>2022 Q2</c:v>
+                </c:pt>
+                <c:pt idx="6">
+                  <c:v>2022 Q3</c:v>
+                </c:pt>
+                <c:pt idx="7">
+                  <c:v>2022 Q4</c:v>
+                </c:pt>
+                <c:pt idx="8">
                   <c:v>2023 Q1</c:v>
                 </c:pt>
-                <c:pt idx="1">
+                <c:pt idx="9">
                   <c:v>2023 Q2</c:v>
                 </c:pt>
-                <c:pt idx="2">
+                <c:pt idx="10">
                   <c:v>2023 Q3</c:v>
                 </c:pt>
-                <c:pt idx="3">
+                <c:pt idx="11">
                   <c:v>2023 Q4</c:v>
                 </c:pt>
-                <c:pt idx="4">
+                <c:pt idx="12">
                   <c:v>2024 Q1</c:v>
                 </c:pt>
-                <c:pt idx="5">
+                <c:pt idx="13">
                   <c:v>2024 Q2</c:v>
                 </c:pt>
-                <c:pt idx="6">
+                <c:pt idx="14">
                   <c:v>2024 Q3</c:v>
                 </c:pt>
-                <c:pt idx="7">
+                <c:pt idx="15">
                   <c:v>2024 Q4</c:v>
+                </c:pt>
+                <c:pt idx="16">
+                  <c:v>2025 Q1</c:v>
+                </c:pt>
+                <c:pt idx="17">
+                  <c:v>2025 Q2</c:v>
+                </c:pt>
+                <c:pt idx="18">
+                  <c:v>2025 Q3</c:v>
+                </c:pt>
+                <c:pt idx="19">
+                  <c:v>2025 Q4</c:v>
+                </c:pt>
+                <c:pt idx="20">
+                  <c:v>2026 Q1</c:v>
                 </c:pt>
               </c:strCache>
             </c:strRef>
           </c:cat>
           <c:val>
             <c:numRef>
-              <c:f>Sheet1!$B$2:$B$9</c:f>
+              <c:f>Sheet1!$B$2:$B$22</c:f>
               <c:numCache>
                 <c:formatCode>General</c:formatCode>
-                <c:ptCount val="8"/>
+                <c:ptCount val="21"/>
                 <c:pt idx="0">
-                  <c:v>660.0</c:v>
+                  <c:v>970.0</c:v>
                 </c:pt>
                 <c:pt idx="1">
-                  <c:v>755.0</c:v>
+                  <c:v>1082.0</c:v>
                 </c:pt>
                 <c:pt idx="2">
-                  <c:v>700.0</c:v>
+                  <c:v>1211.0</c:v>
                 </c:pt>
                 <c:pt idx="3">
-                  <c:v>850.0</c:v>
+                  <c:v>1272.0</c:v>
                 </c:pt>
                 <c:pt idx="4">
-                  <c:v>950.0</c:v>
+                  <c:v>1461.0</c:v>
                 </c:pt>
                 <c:pt idx="5">
-                  <c:v>1050.0</c:v>
+                  <c:v>1579.0</c:v>
                 </c:pt>
                 <c:pt idx="6">
-                  <c:v>990.0</c:v>
+                  <c:v>1742.0</c:v>
                 </c:pt>
                 <c:pt idx="7">
-                  <c:v>1170.0</c:v>
+                  <c:v>1677.0</c:v>
+                </c:pt>
+                <c:pt idx="8">
+                  <c:v>2100.0</c:v>
+                </c:pt>
+                <c:pt idx="9">
+                  <c:v>2066.0</c:v>
+                </c:pt>
+                <c:pt idx="10">
+                  <c:v>2198.0</c:v>
+                </c:pt>
+                <c:pt idx="11">
+                  <c:v>2028.0</c:v>
+                </c:pt>
+                <c:pt idx="12">
+                  <c:v>2324.0</c:v>
+                </c:pt>
+                <c:pt idx="13">
+                  <c:v>2363.0</c:v>
+                </c:pt>
+                <c:pt idx="14">
+                  <c:v>2431.0</c:v>
+                </c:pt>
+                <c:pt idx="15">
+                  <c:v>2342.0</c:v>
+                </c:pt>
+                <c:pt idx="16">
+                  <c:v>2545.0</c:v>
+                </c:pt>
+                <c:pt idx="17">
+                  <c:v>2543.0</c:v>
+                </c:pt>
+                <c:pt idx="18">
+                  <c:v>2452.0</c:v>
+                </c:pt>
+                <c:pt idx="19">
+                  <c:v>2190.0</c:v>
+                </c:pt>
+                <c:pt idx="20">
+                  <c:v>40.0</c:v>
                 </c:pt>
               </c:numCache>
             </c:numRef>
@@ -3312,7 +3390,7 @@
         <p:spPr>
           <a:xfrm>
             <a:off x="228600" y="800100"/>
-            <a:ext cx="8686800" cy="457200"/>
+            <a:ext cx="8686800" cy="400000"/>
           </a:xfrm>
           <a:prstGeom prst="roundRect">
             <a:avLst>
@@ -3366,8 +3444,8 @@
         </p:nvSpPr>
         <p:spPr>
           <a:xfrm>
-            <a:off x="228600" y="1371600"/>
-            <a:ext cx="2819400" cy="207000"/>
+            <a:off x="228600" y="1314400"/>
+            <a:ext cx="2819400" cy="194300"/>
           </a:xfrm>
           <a:prstGeom prst="rect">
             <a:avLst/>
@@ -3403,8 +3481,8 @@
           <p:nvPr/>
         </p:nvGraphicFramePr>
         <p:xfrm>
-          <a:off x="228600" y="1578600"/>
-          <a:ext cx="2819399" cy="424800"/>
+          <a:off x="228600" y="1508700"/>
+          <a:ext cx="2819399" cy="550050"/>
         </p:xfrm>
         <a:graphic>
           <a:graphicData uri="http://schemas.openxmlformats.org/drawingml/2006/table">
@@ -3416,14 +3494,14 @@
                 <a:gridCol w="1832610"/>
                 <a:gridCol w="986789"/>
               </a:tblGrid>
-              <a:tr h="212400">
-                <a:tc>
-                  <a:txBody>
-                    <a:bodyPr/>
-                    <a:lstStyle/>
-                    <a:p>
-                      <a:pPr>
-                        <a:defRPr sz="800" b="1">
+              <a:tr h="183350">
+                <a:tc>
+                  <a:txBody>
+                    <a:bodyPr/>
+                    <a:lstStyle/>
+                    <a:p>
+                      <a:pPr>
+                        <a:defRPr sz="750" b="1">
                           <a:solidFill>
                             <a:srgbClr val="FFFFFF"/>
                           </a:solidFill>
@@ -3446,7 +3524,7 @@
                     <a:lstStyle/>
                     <a:p>
                       <a:pPr>
-                        <a:defRPr sz="800" b="1">
+                        <a:defRPr sz="750" b="1">
                           <a:solidFill>
                             <a:srgbClr val="FFFFFF"/>
                           </a:solidFill>
@@ -3464,21 +3542,21 @@
                   </a:tcPr>
                 </a:tc>
               </a:tr>
-              <a:tr h="212400">
-                <a:tc>
-                  <a:txBody>
-                    <a:bodyPr/>
-                    <a:lstStyle/>
-                    <a:p>
-                      <a:pPr>
-                        <a:defRPr sz="800" b="0">
-                          <a:solidFill>
-                            <a:srgbClr val="000000"/>
-                          </a:solidFill>
-                        </a:defRPr>
-                      </a:pPr>
-                      <a:r>
-                        <a:t>Design Suite</a:t>
+              <a:tr h="183350">
+                <a:tc>
+                  <a:txBody>
+                    <a:bodyPr/>
+                    <a:lstStyle/>
+                    <a:p>
+                      <a:pPr>
+                        <a:defRPr sz="750" b="0">
+                          <a:solidFill>
+                            <a:srgbClr val="000000"/>
+                          </a:solidFill>
+                        </a:defRPr>
+                      </a:pPr>
+                      <a:r>
+                        <a:t>Design Suite Bundle</a:t>
                       </a:r>
                     </a:p>
                   </a:txBody>
@@ -3494,7 +3572,7 @@
                     <a:lstStyle/>
                     <a:p>
                       <a:pPr>
-                        <a:defRPr sz="800" b="0">
+                        <a:defRPr sz="750" b="0">
                           <a:solidFill>
                             <a:srgbClr val="000000"/>
                           </a:solidFill>
@@ -3508,6 +3586,54 @@
                   <a:tcPr>
                     <a:solidFill>
                       <a:srgbClr val="FFFFFF"/>
+                    </a:solidFill>
+                  </a:tcPr>
+                </a:tc>
+              </a:tr>
+              <a:tr h="183350">
+                <a:tc>
+                  <a:txBody>
+                    <a:bodyPr/>
+                    <a:lstStyle/>
+                    <a:p>
+                      <a:pPr>
+                        <a:defRPr sz="750" b="0">
+                          <a:solidFill>
+                            <a:srgbClr val="000000"/>
+                          </a:solidFill>
+                        </a:defRPr>
+                      </a:pPr>
+                      <a:r>
+                        <a:t>Simulation Bundle</a:t>
+                      </a:r>
+                    </a:p>
+                  </a:txBody>
+                  <a:tcPr>
+                    <a:solidFill>
+                      <a:srgbClr val="F2F2F2"/>
+                    </a:solidFill>
+                  </a:tcPr>
+                </a:tc>
+                <a:tc>
+                  <a:txBody>
+                    <a:bodyPr/>
+                    <a:lstStyle/>
+                    <a:p>
+                      <a:pPr>
+                        <a:defRPr sz="750" b="0">
+                          <a:solidFill>
+                            <a:srgbClr val="000000"/>
+                          </a:solidFill>
+                        </a:defRPr>
+                      </a:pPr>
+                      <a:r>
+                        <a:t>Suite</a:t>
+                      </a:r>
+                    </a:p>
+                  </a:txBody>
+                  <a:tcPr>
+                    <a:solidFill>
+                      <a:srgbClr val="F2F2F2"/>
                     </a:solidFill>
                   </a:tcPr>
                 </a:tc>
@@ -3524,8 +3650,8 @@
         </p:nvSpPr>
         <p:spPr>
           <a:xfrm>
-            <a:off x="228600" y="2103400"/>
-            <a:ext cx="2819400" cy="207000"/>
+            <a:off x="228600" y="2173050"/>
+            <a:ext cx="2819400" cy="194300"/>
           </a:xfrm>
           <a:prstGeom prst="rect">
             <a:avLst/>
@@ -3561,8 +3687,8 @@
           <p:nvPr/>
         </p:nvGraphicFramePr>
         <p:xfrm>
-          <a:off x="228600" y="2310400"/>
-          <a:ext cx="2819400" cy="637200"/>
+          <a:off x="228600" y="2367350"/>
+          <a:ext cx="2819400" cy="948500"/>
         </p:xfrm>
         <a:graphic>
           <a:graphicData uri="http://schemas.openxmlformats.org/drawingml/2006/table">
@@ -3571,11 +3697,11 @@
                 <a:tableStyleId>{5C22544A-7EE6-4342-B048-85BDC9FD1C3A}</a:tableStyleId>
               </a:tblPr>
               <a:tblGrid>
-                <a:gridCol w="422910"/>
-                <a:gridCol w="1550670"/>
-                <a:gridCol w="845820"/>
+                <a:gridCol w="394716"/>
+                <a:gridCol w="1522476"/>
+                <a:gridCol w="902208"/>
               </a:tblGrid>
-              <a:tr h="212400">
+              <a:tr h="189700">
                 <a:tc>
                   <a:txBody>
                     <a:bodyPr/>
@@ -3646,7 +3772,7 @@
                   </a:tcPr>
                 </a:tc>
               </a:tr>
-              <a:tr h="212400">
+              <a:tr h="189700">
                 <a:tc>
                   <a:txBody>
                     <a:bodyPr/>
@@ -3717,7 +3843,7 @@
                   </a:tcPr>
                 </a:tc>
               </a:tr>
-              <a:tr h="212400">
+              <a:tr h="189700">
                 <a:tc>
                   <a:txBody>
                     <a:bodyPr/>
@@ -3755,6 +3881,148 @@
                       </a:pPr>
                       <a:r>
                         <a:t>Revit</a:t>
+                      </a:r>
+                    </a:p>
+                  </a:txBody>
+                  <a:tcPr>
+                    <a:solidFill>
+                      <a:srgbClr val="F2F2F2"/>
+                    </a:solidFill>
+                  </a:tcPr>
+                </a:tc>
+                <a:tc>
+                  <a:txBody>
+                    <a:bodyPr/>
+                    <a:lstStyle/>
+                    <a:p>
+                      <a:pPr>
+                        <a:defRPr sz="800" b="0">
+                          <a:solidFill>
+                            <a:srgbClr val="000000"/>
+                          </a:solidFill>
+                        </a:defRPr>
+                      </a:pPr>
+                      <a:r>
+                        <a:t>Named User</a:t>
+                      </a:r>
+                    </a:p>
+                  </a:txBody>
+                  <a:tcPr>
+                    <a:solidFill>
+                      <a:srgbClr val="F2F2F2"/>
+                    </a:solidFill>
+                  </a:tcPr>
+                </a:tc>
+              </a:tr>
+              <a:tr h="189700">
+                <a:tc>
+                  <a:txBody>
+                    <a:bodyPr/>
+                    <a:lstStyle/>
+                    <a:p>
+                      <a:pPr>
+                        <a:defRPr sz="800" b="0">
+                          <a:solidFill>
+                            <a:srgbClr val="000000"/>
+                          </a:solidFill>
+                        </a:defRPr>
+                      </a:pPr>
+                      <a:r>
+                        <a:t>100</a:t>
+                      </a:r>
+                    </a:p>
+                  </a:txBody>
+                  <a:tcPr>
+                    <a:solidFill>
+                      <a:srgbClr val="FFFFFF"/>
+                    </a:solidFill>
+                  </a:tcPr>
+                </a:tc>
+                <a:tc>
+                  <a:txBody>
+                    <a:bodyPr/>
+                    <a:lstStyle/>
+                    <a:p>
+                      <a:pPr>
+                        <a:defRPr sz="800" b="0">
+                          <a:solidFill>
+                            <a:srgbClr val="000000"/>
+                          </a:solidFill>
+                        </a:defRPr>
+                      </a:pPr>
+                      <a:r>
+                        <a:t>Inventor</a:t>
+                      </a:r>
+                    </a:p>
+                  </a:txBody>
+                  <a:tcPr>
+                    <a:solidFill>
+                      <a:srgbClr val="FFFFFF"/>
+                    </a:solidFill>
+                  </a:tcPr>
+                </a:tc>
+                <a:tc>
+                  <a:txBody>
+                    <a:bodyPr/>
+                    <a:lstStyle/>
+                    <a:p>
+                      <a:pPr>
+                        <a:defRPr sz="800" b="0">
+                          <a:solidFill>
+                            <a:srgbClr val="000000"/>
+                          </a:solidFill>
+                        </a:defRPr>
+                      </a:pPr>
+                      <a:r>
+                        <a:t>Named User</a:t>
+                      </a:r>
+                    </a:p>
+                  </a:txBody>
+                  <a:tcPr>
+                    <a:solidFill>
+                      <a:srgbClr val="FFFFFF"/>
+                    </a:solidFill>
+                  </a:tcPr>
+                </a:tc>
+              </a:tr>
+              <a:tr h="189700">
+                <a:tc>
+                  <a:txBody>
+                    <a:bodyPr/>
+                    <a:lstStyle/>
+                    <a:p>
+                      <a:pPr>
+                        <a:defRPr sz="800" b="0">
+                          <a:solidFill>
+                            <a:srgbClr val="000000"/>
+                          </a:solidFill>
+                        </a:defRPr>
+                      </a:pPr>
+                      <a:r>
+                        <a:t>50</a:t>
+                      </a:r>
+                    </a:p>
+                  </a:txBody>
+                  <a:tcPr>
+                    <a:solidFill>
+                      <a:srgbClr val="F2F2F2"/>
+                    </a:solidFill>
+                  </a:tcPr>
+                </a:tc>
+                <a:tc>
+                  <a:txBody>
+                    <a:bodyPr/>
+                    <a:lstStyle/>
+                    <a:p>
+                      <a:pPr>
+                        <a:defRPr sz="800" b="0">
+                          <a:solidFill>
+                            <a:srgbClr val="000000"/>
+                          </a:solidFill>
+                        </a:defRPr>
+                      </a:pPr>
+                      <a:r>
+                        <a:t>Navisworks</a:t>
                       </a:r>
                     </a:p>
                   </a:txBody>
@@ -3800,8 +4068,8 @@
         </p:nvSpPr>
         <p:spPr>
           <a:xfrm>
-            <a:off x="3162300" y="1371600"/>
-            <a:ext cx="2819400" cy="207000"/>
+            <a:off x="3162300" y="1314400"/>
+            <a:ext cx="2819400" cy="194300"/>
           </a:xfrm>
           <a:prstGeom prst="rect">
             <a:avLst/>
@@ -3837,8 +4105,8 @@
           <p:nvPr/>
         </p:nvGraphicFramePr>
         <p:xfrm>
-          <a:off x="3162300" y="1578600"/>
-          <a:ext cx="2819400" cy="1594485"/>
+          <a:off x="3162300" y="1508700"/>
+          <a:ext cx="2819400" cy="1800250"/>
         </p:xfrm>
         <a:graphic>
           <a:graphicData uri="http://schemas.openxmlformats.org/drawingml/2006/chart">
@@ -3854,8 +4122,8 @@
         </p:nvSpPr>
         <p:spPr>
           <a:xfrm>
-            <a:off x="3162300" y="3253085"/>
-            <a:ext cx="2819400" cy="207000"/>
+            <a:off x="3162300" y="3423250"/>
+            <a:ext cx="2819400" cy="194300"/>
           </a:xfrm>
           <a:prstGeom prst="rect">
             <a:avLst/>
@@ -3891,8 +4159,8 @@
           <p:nvPr/>
         </p:nvGraphicFramePr>
         <p:xfrm>
-          <a:off x="3162300" y="3460085"/>
-          <a:ext cx="2819400" cy="849600"/>
+          <a:off x="3162300" y="3617550"/>
+          <a:ext cx="2819400" cy="733400"/>
         </p:xfrm>
         <a:graphic>
           <a:graphicData uri="http://schemas.openxmlformats.org/drawingml/2006/table">
@@ -3904,14 +4172,14 @@
                 <a:gridCol w="1409700"/>
                 <a:gridCol w="1409700"/>
               </a:tblGrid>
-              <a:tr h="212400">
-                <a:tc>
-                  <a:txBody>
-                    <a:bodyPr/>
-                    <a:lstStyle/>
-                    <a:p>
-                      <a:pPr>
-                        <a:defRPr sz="800" b="1">
+              <a:tr h="183350">
+                <a:tc>
+                  <a:txBody>
+                    <a:bodyPr/>
+                    <a:lstStyle/>
+                    <a:p>
+                      <a:pPr>
+                        <a:defRPr sz="750" b="1">
                           <a:solidFill>
                             <a:srgbClr val="FFFFFF"/>
                           </a:solidFill>
@@ -3934,7 +4202,7 @@
                     <a:lstStyle/>
                     <a:p>
                       <a:pPr>
-                        <a:defRPr sz="800" b="1">
+                        <a:defRPr sz="750" b="1">
                           <a:solidFill>
                             <a:srgbClr val="FFFFFF"/>
                           </a:solidFill>
@@ -3952,21 +4220,21 @@
                   </a:tcPr>
                 </a:tc>
               </a:tr>
-              <a:tr h="212400">
-                <a:tc>
-                  <a:txBody>
-                    <a:bodyPr/>
-                    <a:lstStyle/>
-                    <a:p>
-                      <a:pPr>
-                        <a:defRPr sz="800" b="0">
-                          <a:solidFill>
-                            <a:srgbClr val="000000"/>
-                          </a:solidFill>
-                        </a:defRPr>
-                      </a:pPr>
-                      <a:r>
-                        <a:t>Max Sessions</a:t>
+              <a:tr h="183350">
+                <a:tc>
+                  <a:txBody>
+                    <a:bodyPr/>
+                    <a:lstStyle/>
+                    <a:p>
+                      <a:pPr>
+                        <a:defRPr sz="750" b="0">
+                          <a:solidFill>
+                            <a:srgbClr val="000000"/>
+                          </a:solidFill>
+                        </a:defRPr>
+                      </a:pPr>
+                      <a:r>
+                        <a:t>Peak Sessions</a:t>
                       </a:r>
                     </a:p>
                   </a:txBody>
@@ -3982,14 +4250,14 @@
                     <a:lstStyle/>
                     <a:p>
                       <a:pPr>
-                        <a:defRPr sz="800" b="0">
-                          <a:solidFill>
-                            <a:srgbClr val="000000"/>
-                          </a:solidFill>
-                        </a:defRPr>
-                      </a:pPr>
-                      <a:r>
-                        <a:t>1,170 (2024 Q4)</a:t>
+                        <a:defRPr sz="750" b="0">
+                          <a:solidFill>
+                            <a:srgbClr val="000000"/>
+                          </a:solidFill>
+                        </a:defRPr>
+                      </a:pPr>
+                      <a:r>
+                        <a:t>2,545 (2025 Q1)</a:t>
                       </a:r>
                     </a:p>
                   </a:txBody>
@@ -4000,21 +4268,21 @@
                   </a:tcPr>
                 </a:tc>
               </a:tr>
-              <a:tr h="212400">
-                <a:tc>
-                  <a:txBody>
-                    <a:bodyPr/>
-                    <a:lstStyle/>
-                    <a:p>
-                      <a:pPr>
-                        <a:defRPr sz="800" b="0">
-                          <a:solidFill>
-                            <a:srgbClr val="000000"/>
-                          </a:solidFill>
-                        </a:defRPr>
-                      </a:pPr>
-                      <a:r>
-                        <a:t>Min Sessions</a:t>
+              <a:tr h="183350">
+                <a:tc>
+                  <a:txBody>
+                    <a:bodyPr/>
+                    <a:lstStyle/>
+                    <a:p>
+                      <a:pPr>
+                        <a:defRPr sz="750" b="0">
+                          <a:solidFill>
+                            <a:srgbClr val="000000"/>
+                          </a:solidFill>
+                        </a:defRPr>
+                      </a:pPr>
+                      <a:r>
+                        <a:t>Low Sessions</a:t>
                       </a:r>
                     </a:p>
                   </a:txBody>
@@ -4030,14 +4298,14 @@
                     <a:lstStyle/>
                     <a:p>
                       <a:pPr>
-                        <a:defRPr sz="800" b="0">
-                          <a:solidFill>
-                            <a:srgbClr val="000000"/>
-                          </a:solidFill>
-                        </a:defRPr>
-                      </a:pPr>
-                      <a:r>
-                        <a:t>660 (2023 Q1)</a:t>
+                        <a:defRPr sz="750" b="0">
+                          <a:solidFill>
+                            <a:srgbClr val="000000"/>
+                          </a:solidFill>
+                        </a:defRPr>
+                      </a:pPr>
+                      <a:r>
+                        <a:t>40 (2026 Q1)</a:t>
                       </a:r>
                     </a:p>
                   </a:txBody>
@@ -4048,14 +4316,14 @@
                   </a:tcPr>
                 </a:tc>
               </a:tr>
-              <a:tr h="212400">
-                <a:tc>
-                  <a:txBody>
-                    <a:bodyPr/>
-                    <a:lstStyle/>
-                    <a:p>
-                      <a:pPr>
-                        <a:defRPr sz="800" b="0">
+              <a:tr h="183350">
+                <a:tc>
+                  <a:txBody>
+                    <a:bodyPr/>
+                    <a:lstStyle/>
+                    <a:p>
+                      <a:pPr>
+                        <a:defRPr sz="750" b="0">
                           <a:solidFill>
                             <a:srgbClr val="000000"/>
                           </a:solidFill>
@@ -4078,14 +4346,14 @@
                     <a:lstStyle/>
                     <a:p>
                       <a:pPr>
-                        <a:defRPr sz="800" b="0">
-                          <a:solidFill>
-                            <a:srgbClr val="000000"/>
-                          </a:solidFill>
-                        </a:defRPr>
-                      </a:pPr>
-                      <a:r>
-                        <a:t>+9.0%</a:t>
+                        <a:defRPr sz="750" b="0">
+                          <a:solidFill>
+                            <a:srgbClr val="000000"/>
+                          </a:solidFill>
+                        </a:defRPr>
+                      </a:pPr>
+                      <a:r>
+                        <a:t>-0.4%</a:t>
                       </a:r>
                     </a:p>
                   </a:txBody>
@@ -4108,8 +4376,8 @@
         </p:nvSpPr>
         <p:spPr>
           <a:xfrm>
-            <a:off x="6096000" y="1371600"/>
-            <a:ext cx="2819400" cy="207000"/>
+            <a:off x="6096000" y="1314400"/>
+            <a:ext cx="2819400" cy="194300"/>
           </a:xfrm>
           <a:prstGeom prst="rect">
             <a:avLst/>
@@ -4145,8 +4413,8 @@
           <p:nvPr/>
         </p:nvGraphicFramePr>
         <p:xfrm>
-          <a:off x="6096000" y="1578600"/>
-          <a:ext cx="2819400" cy="1274400"/>
+          <a:off x="6096000" y="1508700"/>
+          <a:ext cx="2819400" cy="1100100"/>
         </p:xfrm>
         <a:graphic>
           <a:graphicData uri="http://schemas.openxmlformats.org/drawingml/2006/table">
@@ -4159,14 +4427,14 @@
                 <a:gridCol w="789432"/>
                 <a:gridCol w="620268"/>
               </a:tblGrid>
-              <a:tr h="212400">
-                <a:tc>
-                  <a:txBody>
-                    <a:bodyPr/>
-                    <a:lstStyle/>
-                    <a:p>
-                      <a:pPr>
-                        <a:defRPr sz="800" b="1">
+              <a:tr h="183350">
+                <a:tc>
+                  <a:txBody>
+                    <a:bodyPr/>
+                    <a:lstStyle/>
+                    <a:p>
+                      <a:pPr>
+                        <a:defRPr sz="750" b="1">
                           <a:solidFill>
                             <a:srgbClr val="FFFFFF"/>
                           </a:solidFill>
@@ -4189,7 +4457,7 @@
                     <a:lstStyle/>
                     <a:p>
                       <a:pPr>
-                        <a:defRPr sz="800" b="1">
+                        <a:defRPr sz="750" b="1">
                           <a:solidFill>
                             <a:srgbClr val="FFFFFF"/>
                           </a:solidFill>
@@ -4212,7 +4480,7 @@
                     <a:lstStyle/>
                     <a:p>
                       <a:pPr>
-                        <a:defRPr sz="800" b="1">
+                        <a:defRPr sz="750" b="1">
                           <a:solidFill>
                             <a:srgbClr val="FFFFFF"/>
                           </a:solidFill>
@@ -4230,21 +4498,21 @@
                   </a:tcPr>
                 </a:tc>
               </a:tr>
-              <a:tr h="212400">
-                <a:tc>
-                  <a:txBody>
-                    <a:bodyPr/>
-                    <a:lstStyle/>
-                    <a:p>
-                      <a:pPr>
-                        <a:defRPr sz="800" b="0">
-                          <a:solidFill>
-                            <a:srgbClr val="000000"/>
-                          </a:solidFill>
-                        </a:defRPr>
-                      </a:pPr>
-                      <a:r>
-                        <a:t>USA, New York</a:t>
+              <a:tr h="183350">
+                <a:tc>
+                  <a:txBody>
+                    <a:bodyPr/>
+                    <a:lstStyle/>
+                    <a:p>
+                      <a:pPr>
+                        <a:defRPr sz="750" b="0">
+                          <a:solidFill>
+                            <a:srgbClr val="000000"/>
+                          </a:solidFill>
+                        </a:defRPr>
+                      </a:pPr>
+                      <a:r>
+                        <a:t>United States, Ontario</a:t>
                       </a:r>
                     </a:p>
                   </a:txBody>
@@ -4260,14 +4528,14 @@
                     <a:lstStyle/>
                     <a:p>
                       <a:pPr>
-                        <a:defRPr sz="800" b="0">
-                          <a:solidFill>
-                            <a:srgbClr val="000000"/>
-                          </a:solidFill>
-                        </a:defRPr>
-                      </a:pPr>
-                      <a:r>
-                        <a:t>420</a:t>
+                        <a:defRPr sz="750" b="0">
+                          <a:solidFill>
+                            <a:srgbClr val="000000"/>
+                          </a:solidFill>
+                        </a:defRPr>
+                      </a:pPr>
+                      <a:r>
+                        <a:t>983</a:t>
                       </a:r>
                     </a:p>
                   </a:txBody>
@@ -4283,14 +4551,14 @@
                     <a:lstStyle/>
                     <a:p>
                       <a:pPr>
-                        <a:defRPr sz="800" b="0">
-                          <a:solidFill>
-                            <a:srgbClr val="000000"/>
-                          </a:solidFill>
-                        </a:defRPr>
-                      </a:pPr>
-                      <a:r>
-                        <a:t>17.6%</a:t>
+                        <a:defRPr sz="750" b="0">
+                          <a:solidFill>
+                            <a:srgbClr val="000000"/>
+                          </a:solidFill>
+                        </a:defRPr>
+                      </a:pPr>
+                      <a:r>
+                        <a:t>50.4%</a:t>
                       </a:r>
                     </a:p>
                   </a:txBody>
@@ -4301,21 +4569,21 @@
                   </a:tcPr>
                 </a:tc>
               </a:tr>
-              <a:tr h="212400">
-                <a:tc>
-                  <a:txBody>
-                    <a:bodyPr/>
-                    <a:lstStyle/>
-                    <a:p>
-                      <a:pPr>
-                        <a:defRPr sz="800" b="0">
-                          <a:solidFill>
-                            <a:srgbClr val="000000"/>
-                          </a:solidFill>
-                        </a:defRPr>
-                      </a:pPr>
-                      <a:r>
-                        <a:t>USA, Chicago</a:t>
+              <a:tr h="183350">
+                <a:tc>
+                  <a:txBody>
+                    <a:bodyPr/>
+                    <a:lstStyle/>
+                    <a:p>
+                      <a:pPr>
+                        <a:defRPr sz="750" b="0">
+                          <a:solidFill>
+                            <a:srgbClr val="000000"/>
+                          </a:solidFill>
+                        </a:defRPr>
+                      </a:pPr>
+                      <a:r>
+                        <a:t>United States, Marion</a:t>
                       </a:r>
                     </a:p>
                   </a:txBody>
@@ -4331,14 +4599,14 @@
                     <a:lstStyle/>
                     <a:p>
                       <a:pPr>
-                        <a:defRPr sz="800" b="0">
-                          <a:solidFill>
-                            <a:srgbClr val="000000"/>
-                          </a:solidFill>
-                        </a:defRPr>
-                      </a:pPr>
-                      <a:r>
-                        <a:t>310</a:t>
+                        <a:defRPr sz="750" b="0">
+                          <a:solidFill>
+                            <a:srgbClr val="000000"/>
+                          </a:solidFill>
+                        </a:defRPr>
+                      </a:pPr>
+                      <a:r>
+                        <a:t>177</a:t>
                       </a:r>
                     </a:p>
                   </a:txBody>
@@ -4354,14 +4622,14 @@
                     <a:lstStyle/>
                     <a:p>
                       <a:pPr>
-                        <a:defRPr sz="800" b="0">
-                          <a:solidFill>
-                            <a:srgbClr val="000000"/>
-                          </a:solidFill>
-                        </a:defRPr>
-                      </a:pPr>
-                      <a:r>
-                        <a:t>13.0%</a:t>
+                        <a:defRPr sz="750" b="0">
+                          <a:solidFill>
+                            <a:srgbClr val="000000"/>
+                          </a:solidFill>
+                        </a:defRPr>
+                      </a:pPr>
+                      <a:r>
+                        <a:t>9.1%</a:t>
                       </a:r>
                     </a:p>
                   </a:txBody>
@@ -4372,21 +4640,21 @@
                   </a:tcPr>
                 </a:tc>
               </a:tr>
-              <a:tr h="212400">
-                <a:tc>
-                  <a:txBody>
-                    <a:bodyPr/>
-                    <a:lstStyle/>
-                    <a:p>
-                      <a:pPr>
-                        <a:defRPr sz="800" b="0">
-                          <a:solidFill>
-                            <a:srgbClr val="000000"/>
-                          </a:solidFill>
-                        </a:defRPr>
-                      </a:pPr>
-                      <a:r>
-                        <a:t>USA, Houston</a:t>
+              <a:tr h="183350">
+                <a:tc>
+                  <a:txBody>
+                    <a:bodyPr/>
+                    <a:lstStyle/>
+                    <a:p>
+                      <a:pPr>
+                        <a:defRPr sz="750" b="0">
+                          <a:solidFill>
+                            <a:srgbClr val="000000"/>
+                          </a:solidFill>
+                        </a:defRPr>
+                      </a:pPr>
+                      <a:r>
+                        <a:t>India, Bengaluru</a:t>
                       </a:r>
                     </a:p>
                   </a:txBody>
@@ -4402,14 +4670,14 @@
                     <a:lstStyle/>
                     <a:p>
                       <a:pPr>
-                        <a:defRPr sz="800" b="0">
-                          <a:solidFill>
-                            <a:srgbClr val="000000"/>
-                          </a:solidFill>
-                        </a:defRPr>
-                      </a:pPr>
-                      <a:r>
-                        <a:t>280</a:t>
+                        <a:defRPr sz="750" b="0">
+                          <a:solidFill>
+                            <a:srgbClr val="000000"/>
+                          </a:solidFill>
+                        </a:defRPr>
+                      </a:pPr>
+                      <a:r>
+                        <a:t>91</a:t>
                       </a:r>
                     </a:p>
                   </a:txBody>
@@ -4425,14 +4693,14 @@
                     <a:lstStyle/>
                     <a:p>
                       <a:pPr>
-                        <a:defRPr sz="800" b="0">
-                          <a:solidFill>
-                            <a:srgbClr val="000000"/>
-                          </a:solidFill>
-                        </a:defRPr>
-                      </a:pPr>
-                      <a:r>
-                        <a:t>11.7%</a:t>
+                        <a:defRPr sz="750" b="0">
+                          <a:solidFill>
+                            <a:srgbClr val="000000"/>
+                          </a:solidFill>
+                        </a:defRPr>
+                      </a:pPr>
+                      <a:r>
+                        <a:t>4.7%</a:t>
                       </a:r>
                     </a:p>
                   </a:txBody>
@@ -4443,21 +4711,21 @@
                   </a:tcPr>
                 </a:tc>
               </a:tr>
-              <a:tr h="212400">
-                <a:tc>
-                  <a:txBody>
-                    <a:bodyPr/>
-                    <a:lstStyle/>
-                    <a:p>
-                      <a:pPr>
-                        <a:defRPr sz="800" b="0">
-                          <a:solidFill>
-                            <a:srgbClr val="000000"/>
-                          </a:solidFill>
-                        </a:defRPr>
-                      </a:pPr>
-                      <a:r>
-                        <a:t>UK, London</a:t>
+              <a:tr h="183350">
+                <a:tc>
+                  <a:txBody>
+                    <a:bodyPr/>
+                    <a:lstStyle/>
+                    <a:p>
+                      <a:pPr>
+                        <a:defRPr sz="750" b="0">
+                          <a:solidFill>
+                            <a:srgbClr val="000000"/>
+                          </a:solidFill>
+                        </a:defRPr>
+                      </a:pPr>
+                      <a:r>
+                        <a:t>Singapore, Singapore</a:t>
                       </a:r>
                     </a:p>
                   </a:txBody>
@@ -4473,14 +4741,14 @@
                     <a:lstStyle/>
                     <a:p>
                       <a:pPr>
-                        <a:defRPr sz="800" b="0">
-                          <a:solidFill>
-                            <a:srgbClr val="000000"/>
-                          </a:solidFill>
-                        </a:defRPr>
-                      </a:pPr>
-                      <a:r>
-                        <a:t>220</a:t>
+                        <a:defRPr sz="750" b="0">
+                          <a:solidFill>
+                            <a:srgbClr val="000000"/>
+                          </a:solidFill>
+                        </a:defRPr>
+                      </a:pPr>
+                      <a:r>
+                        <a:t>73</a:t>
                       </a:r>
                     </a:p>
                   </a:txBody>
@@ -4496,14 +4764,14 @@
                     <a:lstStyle/>
                     <a:p>
                       <a:pPr>
-                        <a:defRPr sz="800" b="0">
-                          <a:solidFill>
-                            <a:srgbClr val="000000"/>
-                          </a:solidFill>
-                        </a:defRPr>
-                      </a:pPr>
-                      <a:r>
-                        <a:t>9.2%</a:t>
+                        <a:defRPr sz="750" b="0">
+                          <a:solidFill>
+                            <a:srgbClr val="000000"/>
+                          </a:solidFill>
+                        </a:defRPr>
+                      </a:pPr>
+                      <a:r>
+                        <a:t>3.7%</a:t>
                       </a:r>
                     </a:p>
                   </a:txBody>
@@ -4514,21 +4782,21 @@
                   </a:tcPr>
                 </a:tc>
               </a:tr>
-              <a:tr h="212400">
-                <a:tc>
-                  <a:txBody>
-                    <a:bodyPr/>
-                    <a:lstStyle/>
-                    <a:p>
-                      <a:pPr>
-                        <a:defRPr sz="800" b="0">
-                          <a:solidFill>
-                            <a:srgbClr val="000000"/>
-                          </a:solidFill>
-                        </a:defRPr>
-                      </a:pPr>
-                      <a:r>
-                        <a:t>USA, San Francisco</a:t>
+              <a:tr h="183350">
+                <a:tc>
+                  <a:txBody>
+                    <a:bodyPr/>
+                    <a:lstStyle/>
+                    <a:p>
+                      <a:pPr>
+                        <a:defRPr sz="750" b="0">
+                          <a:solidFill>
+                            <a:srgbClr val="000000"/>
+                          </a:solidFill>
+                        </a:defRPr>
+                      </a:pPr>
+                      <a:r>
+                        <a:t>United States, Tucson</a:t>
                       </a:r>
                     </a:p>
                   </a:txBody>
@@ -4544,14 +4812,14 @@
                     <a:lstStyle/>
                     <a:p>
                       <a:pPr>
-                        <a:defRPr sz="800" b="0">
-                          <a:solidFill>
-                            <a:srgbClr val="000000"/>
-                          </a:solidFill>
-                        </a:defRPr>
-                      </a:pPr>
-                      <a:r>
-                        <a:t>195</a:t>
+                        <a:defRPr sz="750" b="0">
+                          <a:solidFill>
+                            <a:srgbClr val="000000"/>
+                          </a:solidFill>
+                        </a:defRPr>
+                      </a:pPr>
+                      <a:r>
+                        <a:t>37</a:t>
                       </a:r>
                     </a:p>
                   </a:txBody>
@@ -4567,14 +4835,14 @@
                     <a:lstStyle/>
                     <a:p>
                       <a:pPr>
-                        <a:defRPr sz="800" b="0">
-                          <a:solidFill>
-                            <a:srgbClr val="000000"/>
-                          </a:solidFill>
-                        </a:defRPr>
-                      </a:pPr>
-                      <a:r>
-                        <a:t>8.2%</a:t>
+                        <a:defRPr sz="750" b="0">
+                          <a:solidFill>
+                            <a:srgbClr val="000000"/>
+                          </a:solidFill>
+                        </a:defRPr>
+                      </a:pPr>
+                      <a:r>
+                        <a:t>1.9%</a:t>
                       </a:r>
                     </a:p>
                   </a:txBody>
@@ -4597,8 +4865,8 @@
         </p:nvSpPr>
         <p:spPr>
           <a:xfrm>
-            <a:off x="6096000" y="2933000"/>
-            <a:ext cx="2819400" cy="207000"/>
+            <a:off x="6096000" y="2723100"/>
+            <a:ext cx="2819400" cy="194300"/>
           </a:xfrm>
           <a:prstGeom prst="rect">
             <a:avLst/>
@@ -4634,8 +4902,8 @@
           <p:nvPr/>
         </p:nvGraphicFramePr>
         <p:xfrm>
-          <a:off x="6096000" y="3140000"/>
-          <a:ext cx="2819400" cy="1274400"/>
+          <a:off x="6096000" y="2917400"/>
+          <a:ext cx="2819400" cy="4244800"/>
         </p:xfrm>
         <a:graphic>
           <a:graphicData uri="http://schemas.openxmlformats.org/drawingml/2006/table">
@@ -4644,18 +4912,18 @@
                 <a:tableStyleId>{5C22544A-7EE6-4342-B048-85BDC9FD1C3A}</a:tableStyleId>
               </a:tblPr>
               <a:tblGrid>
-                <a:gridCol w="1127760"/>
+                <a:gridCol w="1184148"/>
                 <a:gridCol w="845820"/>
-                <a:gridCol w="845820"/>
+                <a:gridCol w="789432"/>
               </a:tblGrid>
-              <a:tr h="212400">
-                <a:tc>
-                  <a:txBody>
-                    <a:bodyPr/>
-                    <a:lstStyle/>
-                    <a:p>
-                      <a:pPr>
-                        <a:defRPr sz="800" b="1">
+              <a:tr h="151600">
+                <a:tc>
+                  <a:txBody>
+                    <a:bodyPr/>
+                    <a:lstStyle/>
+                    <a:p>
+                      <a:pPr>
+                        <a:defRPr sz="500" b="1">
                           <a:solidFill>
                             <a:srgbClr val="FFFFFF"/>
                           </a:solidFill>
@@ -4678,7 +4946,7 @@
                     <a:lstStyle/>
                     <a:p>
                       <a:pPr>
-                        <a:defRPr sz="800" b="1">
+                        <a:defRPr sz="500" b="1">
                           <a:solidFill>
                             <a:srgbClr val="FFFFFF"/>
                           </a:solidFill>
@@ -4701,7 +4969,7 @@
                     <a:lstStyle/>
                     <a:p>
                       <a:pPr>
-                        <a:defRPr sz="800" b="1">
+                        <a:defRPr sz="500" b="1">
                           <a:solidFill>
                             <a:srgbClr val="FFFFFF"/>
                           </a:solidFill>
@@ -4719,21 +4987,21 @@
                   </a:tcPr>
                 </a:tc>
               </a:tr>
-              <a:tr h="212400">
-                <a:tc>
-                  <a:txBody>
-                    <a:bodyPr/>
-                    <a:lstStyle/>
-                    <a:p>
-                      <a:pPr>
-                        <a:defRPr sz="800" b="0">
-                          <a:solidFill>
-                            <a:srgbClr val="000000"/>
-                          </a:solidFill>
-                        </a:defRPr>
-                      </a:pPr>
-                      <a:r>
-                        <a:t>AutoCAD</a:t>
+              <a:tr h="151600">
+                <a:tc>
+                  <a:txBody>
+                    <a:bodyPr/>
+                    <a:lstStyle/>
+                    <a:p>
+                      <a:pPr>
+                        <a:defRPr sz="500" b="0">
+                          <a:solidFill>
+                            <a:srgbClr val="000000"/>
+                          </a:solidFill>
+                        </a:defRPr>
+                      </a:pPr>
+                      <a:r>
+                        <a:t>LabVIEW</a:t>
                       </a:r>
                     </a:p>
                   </a:txBody>
@@ -4749,14 +5017,14 @@
                     <a:lstStyle/>
                     <a:p>
                       <a:pPr>
-                        <a:defRPr sz="800" b="0">
-                          <a:solidFill>
-                            <a:srgbClr val="000000"/>
-                          </a:solidFill>
-                        </a:defRPr>
-                      </a:pPr>
-                      <a:r>
-                        <a:t>2024</a:t>
+                        <a:defRPr sz="500" b="0">
+                          <a:solidFill>
+                            <a:srgbClr val="000000"/>
+                          </a:solidFill>
+                        </a:defRPr>
+                      </a:pPr>
+                      <a:r>
+                        <a:t>2020</a:t>
                       </a:r>
                     </a:p>
                   </a:txBody>
@@ -4772,14 +5040,14 @@
                     <a:lstStyle/>
                     <a:p>
                       <a:pPr>
-                        <a:defRPr sz="800" b="0">
-                          <a:solidFill>
-                            <a:srgbClr val="000000"/>
-                          </a:solidFill>
-                        </a:defRPr>
-                      </a:pPr>
-                      <a:r>
-                        <a:t>685</a:t>
+                        <a:defRPr sz="500" b="0">
+                          <a:solidFill>
+                            <a:srgbClr val="000000"/>
+                          </a:solidFill>
+                        </a:defRPr>
+                      </a:pPr>
+                      <a:r>
+                        <a:t>5,305</a:t>
                       </a:r>
                     </a:p>
                   </a:txBody>
@@ -4790,21 +5058,21 @@
                   </a:tcPr>
                 </a:tc>
               </a:tr>
-              <a:tr h="212400">
-                <a:tc>
-                  <a:txBody>
-                    <a:bodyPr/>
-                    <a:lstStyle/>
-                    <a:p>
-                      <a:pPr>
-                        <a:defRPr sz="800" b="0">
-                          <a:solidFill>
-                            <a:srgbClr val="000000"/>
-                          </a:solidFill>
-                        </a:defRPr>
-                      </a:pPr>
-                      <a:r>
-                        <a:t>Revit</a:t>
+              <a:tr h="151600">
+                <a:tc>
+                  <a:txBody>
+                    <a:bodyPr/>
+                    <a:lstStyle/>
+                    <a:p>
+                      <a:pPr>
+                        <a:defRPr sz="500" b="0">
+                          <a:solidFill>
+                            <a:srgbClr val="000000"/>
+                          </a:solidFill>
+                        </a:defRPr>
+                      </a:pPr>
+                      <a:r>
+                        <a:t>MAX</a:t>
                       </a:r>
                     </a:p>
                   </a:txBody>
@@ -4820,14 +5088,14 @@
                     <a:lstStyle/>
                     <a:p>
                       <a:pPr>
-                        <a:defRPr sz="800" b="0">
-                          <a:solidFill>
-                            <a:srgbClr val="000000"/>
-                          </a:solidFill>
-                        </a:defRPr>
-                      </a:pPr>
-                      <a:r>
-                        <a:t>2024</a:t>
+                        <a:defRPr sz="500" b="0">
+                          <a:solidFill>
+                            <a:srgbClr val="000000"/>
+                          </a:solidFill>
+                        </a:defRPr>
+                      </a:pPr>
+                      <a:r>
+                        <a:t>20.0.0</a:t>
                       </a:r>
                     </a:p>
                   </a:txBody>
@@ -4843,14 +5111,14 @@
                     <a:lstStyle/>
                     <a:p>
                       <a:pPr>
-                        <a:defRPr sz="800" b="0">
-                          <a:solidFill>
-                            <a:srgbClr val="000000"/>
-                          </a:solidFill>
-                        </a:defRPr>
-                      </a:pPr>
-                      <a:r>
-                        <a:t>530</a:t>
+                        <a:defRPr sz="500" b="0">
+                          <a:solidFill>
+                            <a:srgbClr val="000000"/>
+                          </a:solidFill>
+                        </a:defRPr>
+                      </a:pPr>
+                      <a:r>
+                        <a:t>3,120</a:t>
                       </a:r>
                     </a:p>
                   </a:txBody>
@@ -4861,21 +5129,21 @@
                   </a:tcPr>
                 </a:tc>
               </a:tr>
-              <a:tr h="212400">
-                <a:tc>
-                  <a:txBody>
-                    <a:bodyPr/>
-                    <a:lstStyle/>
-                    <a:p>
-                      <a:pPr>
-                        <a:defRPr sz="800" b="0">
-                          <a:solidFill>
-                            <a:srgbClr val="000000"/>
-                          </a:solidFill>
-                        </a:defRPr>
-                      </a:pPr>
-                      <a:r>
-                        <a:t>Inventor</a:t>
+              <a:tr h="151600">
+                <a:tc>
+                  <a:txBody>
+                    <a:bodyPr/>
+                    <a:lstStyle/>
+                    <a:p>
+                      <a:pPr>
+                        <a:defRPr sz="500" b="0">
+                          <a:solidFill>
+                            <a:srgbClr val="000000"/>
+                          </a:solidFill>
+                        </a:defRPr>
+                      </a:pPr>
+                      <a:r>
+                        <a:t>TestStand</a:t>
                       </a:r>
                     </a:p>
                   </a:txBody>
@@ -4891,14 +5159,14 @@
                     <a:lstStyle/>
                     <a:p>
                       <a:pPr>
-                        <a:defRPr sz="800" b="0">
-                          <a:solidFill>
-                            <a:srgbClr val="000000"/>
-                          </a:solidFill>
-                        </a:defRPr>
-                      </a:pPr>
-                      <a:r>
-                        <a:t>2024</a:t>
+                        <a:defRPr sz="500" b="0">
+                          <a:solidFill>
+                            <a:srgbClr val="000000"/>
+                          </a:solidFill>
+                        </a:defRPr>
+                      </a:pPr>
+                      <a:r>
+                        <a:t>2019</a:t>
                       </a:r>
                     </a:p>
                   </a:txBody>
@@ -4914,14 +5182,14 @@
                     <a:lstStyle/>
                     <a:p>
                       <a:pPr>
-                        <a:defRPr sz="800" b="0">
-                          <a:solidFill>
-                            <a:srgbClr val="000000"/>
-                          </a:solidFill>
-                        </a:defRPr>
-                      </a:pPr>
-                      <a:r>
-                        <a:t>233</a:t>
+                        <a:defRPr sz="500" b="0">
+                          <a:solidFill>
+                            <a:srgbClr val="000000"/>
+                          </a:solidFill>
+                        </a:defRPr>
+                      </a:pPr>
+                      <a:r>
+                        <a:t>1,880</a:t>
                       </a:r>
                     </a:p>
                   </a:txBody>
@@ -4932,21 +5200,21 @@
                   </a:tcPr>
                 </a:tc>
               </a:tr>
-              <a:tr h="212400">
-                <a:tc>
-                  <a:txBody>
-                    <a:bodyPr/>
-                    <a:lstStyle/>
-                    <a:p>
-                      <a:pPr>
-                        <a:defRPr sz="800" b="0">
-                          <a:solidFill>
-                            <a:srgbClr val="000000"/>
-                          </a:solidFill>
-                        </a:defRPr>
-                      </a:pPr>
-                      <a:r>
-                        <a:t>Navisworks</a:t>
+              <a:tr h="151600">
+                <a:tc>
+                  <a:txBody>
+                    <a:bodyPr/>
+                    <a:lstStyle/>
+                    <a:p>
+                      <a:pPr>
+                        <a:defRPr sz="500" b="0">
+                          <a:solidFill>
+                            <a:srgbClr val="000000"/>
+                          </a:solidFill>
+                        </a:defRPr>
+                      </a:pPr>
+                      <a:r>
+                        <a:t>CVI</a:t>
                       </a:r>
                     </a:p>
                   </a:txBody>
@@ -4962,14 +5230,14 @@
                     <a:lstStyle/>
                     <a:p>
                       <a:pPr>
-                        <a:defRPr sz="800" b="0">
-                          <a:solidFill>
-                            <a:srgbClr val="000000"/>
-                          </a:solidFill>
-                        </a:defRPr>
-                      </a:pPr>
-                      <a:r>
-                        <a:t>2024</a:t>
+                        <a:defRPr sz="500" b="0">
+                          <a:solidFill>
+                            <a:srgbClr val="000000"/>
+                          </a:solidFill>
+                        </a:defRPr>
+                      </a:pPr>
+                      <a:r>
+                        <a:t>19.0.0.49155</a:t>
                       </a:r>
                     </a:p>
                   </a:txBody>
@@ -4985,14 +5253,14 @@
                     <a:lstStyle/>
                     <a:p>
                       <a:pPr>
-                        <a:defRPr sz="800" b="0">
-                          <a:solidFill>
-                            <a:srgbClr val="000000"/>
-                          </a:solidFill>
-                        </a:defRPr>
-                      </a:pPr>
-                      <a:r>
-                        <a:t>113</a:t>
+                        <a:defRPr sz="500" b="0">
+                          <a:solidFill>
+                            <a:srgbClr val="000000"/>
+                          </a:solidFill>
+                        </a:defRPr>
+                      </a:pPr>
+                      <a:r>
+                        <a:t>838</a:t>
                       </a:r>
                     </a:p>
                   </a:txBody>
@@ -5003,21 +5271,21 @@
                   </a:tcPr>
                 </a:tc>
               </a:tr>
-              <a:tr h="212400">
-                <a:tc>
-                  <a:txBody>
-                    <a:bodyPr/>
-                    <a:lstStyle/>
-                    <a:p>
-                      <a:pPr>
-                        <a:defRPr sz="800" b="0">
-                          <a:solidFill>
-                            <a:srgbClr val="000000"/>
-                          </a:solidFill>
-                        </a:defRPr>
-                      </a:pPr>
-                      <a:r>
-                        <a:t>Civil 3D</a:t>
+              <a:tr h="151600">
+                <a:tc>
+                  <a:txBody>
+                    <a:bodyPr/>
+                    <a:lstStyle/>
+                    <a:p>
+                      <a:pPr>
+                        <a:defRPr sz="500" b="0">
+                          <a:solidFill>
+                            <a:srgbClr val="000000"/>
+                          </a:solidFill>
+                        </a:defRPr>
+                      </a:pPr>
+                      <a:r>
+                        <a:t>Vision Development M</a:t>
                       </a:r>
                     </a:p>
                   </a:txBody>
@@ -5033,14 +5301,14 @@
                     <a:lstStyle/>
                     <a:p>
                       <a:pPr>
-                        <a:defRPr sz="800" b="0">
-                          <a:solidFill>
-                            <a:srgbClr val="000000"/>
-                          </a:solidFill>
-                        </a:defRPr>
-                      </a:pPr>
-                      <a:r>
-                        <a:t>2024</a:t>
+                        <a:defRPr sz="500" b="0">
+                          <a:solidFill>
+                            <a:srgbClr val="000000"/>
+                          </a:solidFill>
+                        </a:defRPr>
+                      </a:pPr>
+                      <a:r>
+                        <a:t>14.0.0</a:t>
                       </a:r>
                     </a:p>
                   </a:txBody>
@@ -5056,14 +5324,1576 @@
                     <a:lstStyle/>
                     <a:p>
                       <a:pPr>
-                        <a:defRPr sz="800" b="0">
-                          <a:solidFill>
-                            <a:srgbClr val="000000"/>
-                          </a:solidFill>
-                        </a:defRPr>
-                      </a:pPr>
-                      <a:r>
-                        <a:t>85</a:t>
+                        <a:defRPr sz="500" b="0">
+                          <a:solidFill>
+                            <a:srgbClr val="000000"/>
+                          </a:solidFill>
+                        </a:defRPr>
+                      </a:pPr>
+                      <a:r>
+                        <a:t>510</a:t>
+                      </a:r>
+                    </a:p>
+                  </a:txBody>
+                  <a:tcPr>
+                    <a:solidFill>
+                      <a:srgbClr val="FFFFFF"/>
+                    </a:solidFill>
+                  </a:tcPr>
+                </a:tc>
+              </a:tr>
+              <a:tr h="151600">
+                <a:tc>
+                  <a:txBody>
+                    <a:bodyPr/>
+                    <a:lstStyle/>
+                    <a:p>
+                      <a:pPr>
+                        <a:defRPr sz="500" b="0">
+                          <a:solidFill>
+                            <a:srgbClr val="000000"/>
+                          </a:solidFill>
+                        </a:defRPr>
+                      </a:pPr>
+                      <a:r>
+                        <a:t>DIAdem</a:t>
+                      </a:r>
+                    </a:p>
+                  </a:txBody>
+                  <a:tcPr>
+                    <a:solidFill>
+                      <a:srgbClr val="F2F2F2"/>
+                    </a:solidFill>
+                  </a:tcPr>
+                </a:tc>
+                <a:tc>
+                  <a:txBody>
+                    <a:bodyPr/>
+                    <a:lstStyle/>
+                    <a:p>
+                      <a:pPr>
+                        <a:defRPr sz="500" b="0">
+                          <a:solidFill>
+                            <a:srgbClr val="000000"/>
+                          </a:solidFill>
+                        </a:defRPr>
+                      </a:pPr>
+                      <a:r>
+                        <a:t>2021</a:t>
+                      </a:r>
+                    </a:p>
+                  </a:txBody>
+                  <a:tcPr>
+                    <a:solidFill>
+                      <a:srgbClr val="F2F2F2"/>
+                    </a:solidFill>
+                  </a:tcPr>
+                </a:tc>
+                <a:tc>
+                  <a:txBody>
+                    <a:bodyPr/>
+                    <a:lstStyle/>
+                    <a:p>
+                      <a:pPr>
+                        <a:defRPr sz="500" b="0">
+                          <a:solidFill>
+                            <a:srgbClr val="000000"/>
+                          </a:solidFill>
+                        </a:defRPr>
+                      </a:pPr>
+                      <a:r>
+                        <a:t>347</a:t>
+                      </a:r>
+                    </a:p>
+                  </a:txBody>
+                  <a:tcPr>
+                    <a:solidFill>
+                      <a:srgbClr val="F2F2F2"/>
+                    </a:solidFill>
+                  </a:tcPr>
+                </a:tc>
+              </a:tr>
+              <a:tr h="151600">
+                <a:tc>
+                  <a:txBody>
+                    <a:bodyPr/>
+                    <a:lstStyle/>
+                    <a:p>
+                      <a:pPr>
+                        <a:defRPr sz="500" b="0">
+                          <a:solidFill>
+                            <a:srgbClr val="000000"/>
+                          </a:solidFill>
+                        </a:defRPr>
+                      </a:pPr>
+                      <a:r>
+                        <a:t>Hardware Configurati</a:t>
+                      </a:r>
+                    </a:p>
+                  </a:txBody>
+                  <a:tcPr>
+                    <a:solidFill>
+                      <a:srgbClr val="FFFFFF"/>
+                    </a:solidFill>
+                  </a:tcPr>
+                </a:tc>
+                <a:tc>
+                  <a:txBody>
+                    <a:bodyPr/>
+                    <a:lstStyle/>
+                    <a:p>
+                      <a:pPr>
+                        <a:defRPr sz="500" b="0">
+                          <a:solidFill>
+                            <a:srgbClr val="000000"/>
+                          </a:solidFill>
+                        </a:defRPr>
+                      </a:pPr>
+                      <a:r>
+                        <a:t>2023 Q3</a:t>
+                      </a:r>
+                    </a:p>
+                  </a:txBody>
+                  <a:tcPr>
+                    <a:solidFill>
+                      <a:srgbClr val="FFFFFF"/>
+                    </a:solidFill>
+                  </a:tcPr>
+                </a:tc>
+                <a:tc>
+                  <a:txBody>
+                    <a:bodyPr/>
+                    <a:lstStyle/>
+                    <a:p>
+                      <a:pPr>
+                        <a:defRPr sz="500" b="0">
+                          <a:solidFill>
+                            <a:srgbClr val="000000"/>
+                          </a:solidFill>
+                        </a:defRPr>
+                      </a:pPr>
+                      <a:r>
+                        <a:t>238</a:t>
+                      </a:r>
+                    </a:p>
+                  </a:txBody>
+                  <a:tcPr>
+                    <a:solidFill>
+                      <a:srgbClr val="FFFFFF"/>
+                    </a:solidFill>
+                  </a:tcPr>
+                </a:tc>
+              </a:tr>
+              <a:tr h="151600">
+                <a:tc>
+                  <a:txBody>
+                    <a:bodyPr/>
+                    <a:lstStyle/>
+                    <a:p>
+                      <a:pPr>
+                        <a:defRPr sz="500" b="0">
+                          <a:solidFill>
+                            <a:srgbClr val="000000"/>
+                          </a:solidFill>
+                        </a:defRPr>
+                      </a:pPr>
+                      <a:r>
+                        <a:t>Requirements Gateway</a:t>
+                      </a:r>
+                    </a:p>
+                  </a:txBody>
+                  <a:tcPr>
+                    <a:solidFill>
+                      <a:srgbClr val="F2F2F2"/>
+                    </a:solidFill>
+                  </a:tcPr>
+                </a:tc>
+                <a:tc>
+                  <a:txBody>
+                    <a:bodyPr/>
+                    <a:lstStyle/>
+                    <a:p>
+                      <a:pPr>
+                        <a:defRPr sz="500" b="0">
+                          <a:solidFill>
+                            <a:srgbClr val="000000"/>
+                          </a:solidFill>
+                        </a:defRPr>
+                      </a:pPr>
+                      <a:r>
+                        <a:t>2018</a:t>
+                      </a:r>
+                    </a:p>
+                  </a:txBody>
+                  <a:tcPr>
+                    <a:solidFill>
+                      <a:srgbClr val="F2F2F2"/>
+                    </a:solidFill>
+                  </a:tcPr>
+                </a:tc>
+                <a:tc>
+                  <a:txBody>
+                    <a:bodyPr/>
+                    <a:lstStyle/>
+                    <a:p>
+                      <a:pPr>
+                        <a:defRPr sz="500" b="0">
+                          <a:solidFill>
+                            <a:srgbClr val="000000"/>
+                          </a:solidFill>
+                        </a:defRPr>
+                      </a:pPr>
+                      <a:r>
+                        <a:t>216</a:t>
+                      </a:r>
+                    </a:p>
+                  </a:txBody>
+                  <a:tcPr>
+                    <a:solidFill>
+                      <a:srgbClr val="F2F2F2"/>
+                    </a:solidFill>
+                  </a:tcPr>
+                </a:tc>
+              </a:tr>
+              <a:tr h="151600">
+                <a:tc>
+                  <a:txBody>
+                    <a:bodyPr/>
+                    <a:lstStyle/>
+                    <a:p>
+                      <a:pPr>
+                        <a:defRPr sz="500" b="0">
+                          <a:solidFill>
+                            <a:srgbClr val="000000"/>
+                          </a:solidFill>
+                        </a:defRPr>
+                      </a:pPr>
+                      <a:r>
+                        <a:t>VeriStand</a:t>
+                      </a:r>
+                    </a:p>
+                  </a:txBody>
+                  <a:tcPr>
+                    <a:solidFill>
+                      <a:srgbClr val="FFFFFF"/>
+                    </a:solidFill>
+                  </a:tcPr>
+                </a:tc>
+                <a:tc>
+                  <a:txBody>
+                    <a:bodyPr/>
+                    <a:lstStyle/>
+                    <a:p>
+                      <a:pPr>
+                        <a:defRPr sz="500" b="0">
+                          <a:solidFill>
+                            <a:srgbClr val="000000"/>
+                          </a:solidFill>
+                        </a:defRPr>
+                      </a:pPr>
+                      <a:r>
+                        <a:t>2020 R6</a:t>
+                      </a:r>
+                    </a:p>
+                  </a:txBody>
+                  <a:tcPr>
+                    <a:solidFill>
+                      <a:srgbClr val="FFFFFF"/>
+                    </a:solidFill>
+                  </a:tcPr>
+                </a:tc>
+                <a:tc>
+                  <a:txBody>
+                    <a:bodyPr/>
+                    <a:lstStyle/>
+                    <a:p>
+                      <a:pPr>
+                        <a:defRPr sz="500" b="0">
+                          <a:solidFill>
+                            <a:srgbClr val="000000"/>
+                          </a:solidFill>
+                        </a:defRPr>
+                      </a:pPr>
+                      <a:r>
+                        <a:t>202</a:t>
+                      </a:r>
+                    </a:p>
+                  </a:txBody>
+                  <a:tcPr>
+                    <a:solidFill>
+                      <a:srgbClr val="FFFFFF"/>
+                    </a:solidFill>
+                  </a:tcPr>
+                </a:tc>
+              </a:tr>
+              <a:tr h="151600">
+                <a:tc>
+                  <a:txBody>
+                    <a:bodyPr/>
+                    <a:lstStyle/>
+                    <a:p>
+                      <a:pPr>
+                        <a:defRPr sz="500" b="0">
+                          <a:solidFill>
+                            <a:srgbClr val="000000"/>
+                          </a:solidFill>
+                        </a:defRPr>
+                      </a:pPr>
+                      <a:r>
+                        <a:t>IMAQdx</a:t>
+                      </a:r>
+                    </a:p>
+                  </a:txBody>
+                  <a:tcPr>
+                    <a:solidFill>
+                      <a:srgbClr val="F2F2F2"/>
+                    </a:solidFill>
+                  </a:tcPr>
+                </a:tc>
+                <a:tc>
+                  <a:txBody>
+                    <a:bodyPr/>
+                    <a:lstStyle/>
+                    <a:p>
+                      <a:pPr>
+                        <a:defRPr sz="500" b="0">
+                          <a:solidFill>
+                            <a:srgbClr val="000000"/>
+                          </a:solidFill>
+                        </a:defRPr>
+                      </a:pPr>
+                      <a:r>
+                        <a:t>23.0.0</a:t>
+                      </a:r>
+                    </a:p>
+                  </a:txBody>
+                  <a:tcPr>
+                    <a:solidFill>
+                      <a:srgbClr val="F2F2F2"/>
+                    </a:solidFill>
+                  </a:tcPr>
+                </a:tc>
+                <a:tc>
+                  <a:txBody>
+                    <a:bodyPr/>
+                    <a:lstStyle/>
+                    <a:p>
+                      <a:pPr>
+                        <a:defRPr sz="500" b="0">
+                          <a:solidFill>
+                            <a:srgbClr val="000000"/>
+                          </a:solidFill>
+                        </a:defRPr>
+                      </a:pPr>
+                      <a:r>
+                        <a:t>177</a:t>
+                      </a:r>
+                    </a:p>
+                  </a:txBody>
+                  <a:tcPr>
+                    <a:solidFill>
+                      <a:srgbClr val="F2F2F2"/>
+                    </a:solidFill>
+                  </a:tcPr>
+                </a:tc>
+              </a:tr>
+              <a:tr h="151600">
+                <a:tc>
+                  <a:txBody>
+                    <a:bodyPr/>
+                    <a:lstStyle/>
+                    <a:p>
+                      <a:pPr>
+                        <a:defRPr sz="500" b="0">
+                          <a:solidFill>
+                            <a:srgbClr val="000000"/>
+                          </a:solidFill>
+                        </a:defRPr>
+                      </a:pPr>
+                      <a:r>
+                        <a:t>InstrumentStudio</a:t>
+                      </a:r>
+                    </a:p>
+                  </a:txBody>
+                  <a:tcPr>
+                    <a:solidFill>
+                      <a:srgbClr val="FFFFFF"/>
+                    </a:solidFill>
+                  </a:tcPr>
+                </a:tc>
+                <a:tc>
+                  <a:txBody>
+                    <a:bodyPr/>
+                    <a:lstStyle/>
+                    <a:p>
+                      <a:pPr>
+                        <a:defRPr sz="500" b="0">
+                          <a:solidFill>
+                            <a:srgbClr val="000000"/>
+                          </a:solidFill>
+                        </a:defRPr>
+                      </a:pPr>
+                      <a:r>
+                        <a:t>21.0.0</a:t>
+                      </a:r>
+                    </a:p>
+                  </a:txBody>
+                  <a:tcPr>
+                    <a:solidFill>
+                      <a:srgbClr val="FFFFFF"/>
+                    </a:solidFill>
+                  </a:tcPr>
+                </a:tc>
+                <a:tc>
+                  <a:txBody>
+                    <a:bodyPr/>
+                    <a:lstStyle/>
+                    <a:p>
+                      <a:pPr>
+                        <a:defRPr sz="500" b="0">
+                          <a:solidFill>
+                            <a:srgbClr val="000000"/>
+                          </a:solidFill>
+                        </a:defRPr>
+                      </a:pPr>
+                      <a:r>
+                        <a:t>166</a:t>
+                      </a:r>
+                    </a:p>
+                  </a:txBody>
+                  <a:tcPr>
+                    <a:solidFill>
+                      <a:srgbClr val="FFFFFF"/>
+                    </a:solidFill>
+                  </a:tcPr>
+                </a:tc>
+              </a:tr>
+              <a:tr h="151600">
+                <a:tc>
+                  <a:txBody>
+                    <a:bodyPr/>
+                    <a:lstStyle/>
+                    <a:p>
+                      <a:pPr>
+                        <a:defRPr sz="500" b="0">
+                          <a:solidFill>
+                            <a:srgbClr val="000000"/>
+                          </a:solidFill>
+                        </a:defRPr>
+                      </a:pPr>
+                      <a:r>
+                        <a:t>MStudio</a:t>
+                      </a:r>
+                    </a:p>
+                  </a:txBody>
+                  <a:tcPr>
+                    <a:solidFill>
+                      <a:srgbClr val="F2F2F2"/>
+                    </a:solidFill>
+                  </a:tcPr>
+                </a:tc>
+                <a:tc>
+                  <a:txBody>
+                    <a:bodyPr/>
+                    <a:lstStyle/>
+                    <a:p>
+                      <a:pPr>
+                        <a:defRPr sz="500" b="0">
+                          <a:solidFill>
+                            <a:srgbClr val="000000"/>
+                          </a:solidFill>
+                        </a:defRPr>
+                      </a:pPr>
+                      <a:r>
+                        <a:t>19</a:t>
+                      </a:r>
+                    </a:p>
+                  </a:txBody>
+                  <a:tcPr>
+                    <a:solidFill>
+                      <a:srgbClr val="F2F2F2"/>
+                    </a:solidFill>
+                  </a:tcPr>
+                </a:tc>
+                <a:tc>
+                  <a:txBody>
+                    <a:bodyPr/>
+                    <a:lstStyle/>
+                    <a:p>
+                      <a:pPr>
+                        <a:defRPr sz="500" b="0">
+                          <a:solidFill>
+                            <a:srgbClr val="000000"/>
+                          </a:solidFill>
+                        </a:defRPr>
+                      </a:pPr>
+                      <a:r>
+                        <a:t>148</a:t>
+                      </a:r>
+                    </a:p>
+                  </a:txBody>
+                  <a:tcPr>
+                    <a:solidFill>
+                      <a:srgbClr val="F2F2F2"/>
+                    </a:solidFill>
+                  </a:tcPr>
+                </a:tc>
+              </a:tr>
+              <a:tr h="151600">
+                <a:tc>
+                  <a:txBody>
+                    <a:bodyPr/>
+                    <a:lstStyle/>
+                    <a:p>
+                      <a:pPr>
+                        <a:defRPr sz="500" b="0">
+                          <a:solidFill>
+                            <a:srgbClr val="000000"/>
+                          </a:solidFill>
+                        </a:defRPr>
+                      </a:pPr>
+                      <a:r>
+                        <a:t>Vision Assistant</a:t>
+                      </a:r>
+                    </a:p>
+                  </a:txBody>
+                  <a:tcPr>
+                    <a:solidFill>
+                      <a:srgbClr val="FFFFFF"/>
+                    </a:solidFill>
+                  </a:tcPr>
+                </a:tc>
+                <a:tc>
+                  <a:txBody>
+                    <a:bodyPr/>
+                    <a:lstStyle/>
+                    <a:p>
+                      <a:pPr>
+                        <a:defRPr sz="500" b="0">
+                          <a:solidFill>
+                            <a:srgbClr val="000000"/>
+                          </a:solidFill>
+                        </a:defRPr>
+                      </a:pPr>
+                      <a:r>
+                        <a:t>19.5.0</a:t>
+                      </a:r>
+                    </a:p>
+                  </a:txBody>
+                  <a:tcPr>
+                    <a:solidFill>
+                      <a:srgbClr val="FFFFFF"/>
+                    </a:solidFill>
+                  </a:tcPr>
+                </a:tc>
+                <a:tc>
+                  <a:txBody>
+                    <a:bodyPr/>
+                    <a:lstStyle/>
+                    <a:p>
+                      <a:pPr>
+                        <a:defRPr sz="500" b="0">
+                          <a:solidFill>
+                            <a:srgbClr val="000000"/>
+                          </a:solidFill>
+                        </a:defRPr>
+                      </a:pPr>
+                      <a:r>
+                        <a:t>81</a:t>
+                      </a:r>
+                    </a:p>
+                  </a:txBody>
+                  <a:tcPr>
+                    <a:solidFill>
+                      <a:srgbClr val="FFFFFF"/>
+                    </a:solidFill>
+                  </a:tcPr>
+                </a:tc>
+              </a:tr>
+              <a:tr h="151600">
+                <a:tc>
+                  <a:txBody>
+                    <a:bodyPr/>
+                    <a:lstStyle/>
+                    <a:p>
+                      <a:pPr>
+                        <a:defRPr sz="500" b="0">
+                          <a:solidFill>
+                            <a:srgbClr val="000000"/>
+                          </a:solidFill>
+                        </a:defRPr>
+                      </a:pPr>
+                      <a:r>
+                        <a:t>LabVIEW NXG</a:t>
+                      </a:r>
+                    </a:p>
+                  </a:txBody>
+                  <a:tcPr>
+                    <a:solidFill>
+                      <a:srgbClr val="F2F2F2"/>
+                    </a:solidFill>
+                  </a:tcPr>
+                </a:tc>
+                <a:tc>
+                  <a:txBody>
+                    <a:bodyPr/>
+                    <a:lstStyle/>
+                    <a:p>
+                      <a:pPr>
+                        <a:defRPr sz="500" b="0">
+                          <a:solidFill>
+                            <a:srgbClr val="000000"/>
+                          </a:solidFill>
+                        </a:defRPr>
+                      </a:pPr>
+                      <a:r>
+                        <a:t>4</a:t>
+                      </a:r>
+                    </a:p>
+                  </a:txBody>
+                  <a:tcPr>
+                    <a:solidFill>
+                      <a:srgbClr val="F2F2F2"/>
+                    </a:solidFill>
+                  </a:tcPr>
+                </a:tc>
+                <a:tc>
+                  <a:txBody>
+                    <a:bodyPr/>
+                    <a:lstStyle/>
+                    <a:p>
+                      <a:pPr>
+                        <a:defRPr sz="500" b="0">
+                          <a:solidFill>
+                            <a:srgbClr val="000000"/>
+                          </a:solidFill>
+                        </a:defRPr>
+                      </a:pPr>
+                      <a:r>
+                        <a:t>71</a:t>
+                      </a:r>
+                    </a:p>
+                  </a:txBody>
+                  <a:tcPr>
+                    <a:solidFill>
+                      <a:srgbClr val="F2F2F2"/>
+                    </a:solidFill>
+                  </a:tcPr>
+                </a:tc>
+              </a:tr>
+              <a:tr h="151600">
+                <a:tc>
+                  <a:txBody>
+                    <a:bodyPr/>
+                    <a:lstStyle/>
+                    <a:p>
+                      <a:pPr>
+                        <a:defRPr sz="500" b="0">
+                          <a:solidFill>
+                            <a:srgbClr val="000000"/>
+                          </a:solidFill>
+                        </a:defRPr>
+                      </a:pPr>
+                      <a:r>
+                        <a:t>FlexLogger</a:t>
+                      </a:r>
+                    </a:p>
+                  </a:txBody>
+                  <a:tcPr>
+                    <a:solidFill>
+                      <a:srgbClr val="FFFFFF"/>
+                    </a:solidFill>
+                  </a:tcPr>
+                </a:tc>
+                <a:tc>
+                  <a:txBody>
+                    <a:bodyPr/>
+                    <a:lstStyle/>
+                    <a:p>
+                      <a:pPr>
+                        <a:defRPr sz="500" b="0">
+                          <a:solidFill>
+                            <a:srgbClr val="000000"/>
+                          </a:solidFill>
+                        </a:defRPr>
+                      </a:pPr>
+                      <a:r>
+                        <a:t>2024 Q2</a:t>
+                      </a:r>
+                    </a:p>
+                  </a:txBody>
+                  <a:tcPr>
+                    <a:solidFill>
+                      <a:srgbClr val="FFFFFF"/>
+                    </a:solidFill>
+                  </a:tcPr>
+                </a:tc>
+                <a:tc>
+                  <a:txBody>
+                    <a:bodyPr/>
+                    <a:lstStyle/>
+                    <a:p>
+                      <a:pPr>
+                        <a:defRPr sz="500" b="0">
+                          <a:solidFill>
+                            <a:srgbClr val="000000"/>
+                          </a:solidFill>
+                        </a:defRPr>
+                      </a:pPr>
+                      <a:r>
+                        <a:t>36</a:t>
+                      </a:r>
+                    </a:p>
+                  </a:txBody>
+                  <a:tcPr>
+                    <a:solidFill>
+                      <a:srgbClr val="FFFFFF"/>
+                    </a:solidFill>
+                  </a:tcPr>
+                </a:tc>
+              </a:tr>
+              <a:tr h="151600">
+                <a:tc>
+                  <a:txBody>
+                    <a:bodyPr/>
+                    <a:lstStyle/>
+                    <a:p>
+                      <a:pPr>
+                        <a:defRPr sz="500" b="0">
+                          <a:solidFill>
+                            <a:srgbClr val="000000"/>
+                          </a:solidFill>
+                        </a:defRPr>
+                      </a:pPr>
+                      <a:r>
+                        <a:t>DAQExpress</a:t>
+                      </a:r>
+                    </a:p>
+                  </a:txBody>
+                  <a:tcPr>
+                    <a:solidFill>
+                      <a:srgbClr val="F2F2F2"/>
+                    </a:solidFill>
+                  </a:tcPr>
+                </a:tc>
+                <a:tc>
+                  <a:txBody>
+                    <a:bodyPr/>
+                    <a:lstStyle/>
+                    <a:p>
+                      <a:pPr>
+                        <a:defRPr sz="500" b="0">
+                          <a:solidFill>
+                            <a:srgbClr val="000000"/>
+                          </a:solidFill>
+                        </a:defRPr>
+                      </a:pPr>
+                      <a:r>
+                        <a:t>5.1</a:t>
+                      </a:r>
+                    </a:p>
+                  </a:txBody>
+                  <a:tcPr>
+                    <a:solidFill>
+                      <a:srgbClr val="F2F2F2"/>
+                    </a:solidFill>
+                  </a:tcPr>
+                </a:tc>
+                <a:tc>
+                  <a:txBody>
+                    <a:bodyPr/>
+                    <a:lstStyle/>
+                    <a:p>
+                      <a:pPr>
+                        <a:defRPr sz="500" b="0">
+                          <a:solidFill>
+                            <a:srgbClr val="000000"/>
+                          </a:solidFill>
+                        </a:defRPr>
+                      </a:pPr>
+                      <a:r>
+                        <a:t>33</a:t>
+                      </a:r>
+                    </a:p>
+                  </a:txBody>
+                  <a:tcPr>
+                    <a:solidFill>
+                      <a:srgbClr val="F2F2F2"/>
+                    </a:solidFill>
+                  </a:tcPr>
+                </a:tc>
+              </a:tr>
+              <a:tr h="151600">
+                <a:tc>
+                  <a:txBody>
+                    <a:bodyPr/>
+                    <a:lstStyle/>
+                    <a:p>
+                      <a:pPr>
+                        <a:defRPr sz="500" b="0">
+                          <a:solidFill>
+                            <a:srgbClr val="000000"/>
+                          </a:solidFill>
+                        </a:defRPr>
+                      </a:pPr>
+                      <a:r>
+                        <a:t>G Web Development So</a:t>
+                      </a:r>
+                    </a:p>
+                  </a:txBody>
+                  <a:tcPr>
+                    <a:solidFill>
+                      <a:srgbClr val="FFFFFF"/>
+                    </a:solidFill>
+                  </a:tcPr>
+                </a:tc>
+                <a:tc>
+                  <a:txBody>
+                    <a:bodyPr/>
+                    <a:lstStyle/>
+                    <a:p>
+                      <a:pPr>
+                        <a:defRPr sz="500" b="0">
+                          <a:solidFill>
+                            <a:srgbClr val="000000"/>
+                          </a:solidFill>
+                        </a:defRPr>
+                      </a:pPr>
+                      <a:r>
+                        <a:t>2022 Q3</a:t>
+                      </a:r>
+                    </a:p>
+                  </a:txBody>
+                  <a:tcPr>
+                    <a:solidFill>
+                      <a:srgbClr val="FFFFFF"/>
+                    </a:solidFill>
+                  </a:tcPr>
+                </a:tc>
+                <a:tc>
+                  <a:txBody>
+                    <a:bodyPr/>
+                    <a:lstStyle/>
+                    <a:p>
+                      <a:pPr>
+                        <a:defRPr sz="500" b="0">
+                          <a:solidFill>
+                            <a:srgbClr val="000000"/>
+                          </a:solidFill>
+                        </a:defRPr>
+                      </a:pPr>
+                      <a:r>
+                        <a:t>25</a:t>
+                      </a:r>
+                    </a:p>
+                  </a:txBody>
+                  <a:tcPr>
+                    <a:solidFill>
+                      <a:srgbClr val="FFFFFF"/>
+                    </a:solidFill>
+                  </a:tcPr>
+                </a:tc>
+              </a:tr>
+              <a:tr h="151600">
+                <a:tc>
+                  <a:txBody>
+                    <a:bodyPr/>
+                    <a:lstStyle/>
+                    <a:p>
+                      <a:pPr>
+                        <a:defRPr sz="500" b="0">
+                          <a:solidFill>
+                            <a:srgbClr val="000000"/>
+                          </a:solidFill>
+                        </a:defRPr>
+                      </a:pPr>
+                      <a:r>
+                        <a:t>LVFPGA</a:t>
+                      </a:r>
+                    </a:p>
+                  </a:txBody>
+                  <a:tcPr>
+                    <a:solidFill>
+                      <a:srgbClr val="F2F2F2"/>
+                    </a:solidFill>
+                  </a:tcPr>
+                </a:tc>
+                <a:tc>
+                  <a:txBody>
+                    <a:bodyPr/>
+                    <a:lstStyle/>
+                    <a:p>
+                      <a:pPr>
+                        <a:defRPr sz="500" b="0">
+                          <a:solidFill>
+                            <a:srgbClr val="000000"/>
+                          </a:solidFill>
+                        </a:defRPr>
+                      </a:pPr>
+                      <a:r>
+                        <a:t>2019</a:t>
+                      </a:r>
+                    </a:p>
+                  </a:txBody>
+                  <a:tcPr>
+                    <a:solidFill>
+                      <a:srgbClr val="F2F2F2"/>
+                    </a:solidFill>
+                  </a:tcPr>
+                </a:tc>
+                <a:tc>
+                  <a:txBody>
+                    <a:bodyPr/>
+                    <a:lstStyle/>
+                    <a:p>
+                      <a:pPr>
+                        <a:defRPr sz="500" b="0">
+                          <a:solidFill>
+                            <a:srgbClr val="000000"/>
+                          </a:solidFill>
+                        </a:defRPr>
+                      </a:pPr>
+                      <a:r>
+                        <a:t>12</a:t>
+                      </a:r>
+                    </a:p>
+                  </a:txBody>
+                  <a:tcPr>
+                    <a:solidFill>
+                      <a:srgbClr val="F2F2F2"/>
+                    </a:solidFill>
+                  </a:tcPr>
+                </a:tc>
+              </a:tr>
+              <a:tr h="151600">
+                <a:tc>
+                  <a:txBody>
+                    <a:bodyPr/>
+                    <a:lstStyle/>
+                    <a:p>
+                      <a:pPr>
+                        <a:defRPr sz="500" b="0">
+                          <a:solidFill>
+                            <a:srgbClr val="000000"/>
+                          </a:solidFill>
+                        </a:defRPr>
+                      </a:pPr>
+                      <a:r>
+                        <a:t>LV-2012-LEGACY_NOT_P</a:t>
+                      </a:r>
+                    </a:p>
+                  </a:txBody>
+                  <a:tcPr>
+                    <a:solidFill>
+                      <a:srgbClr val="FFFFFF"/>
+                    </a:solidFill>
+                  </a:tcPr>
+                </a:tc>
+                <a:tc>
+                  <a:txBody>
+                    <a:bodyPr/>
+                    <a:lstStyle/>
+                    <a:p>
+                      <a:pPr>
+                        <a:defRPr sz="500" b="0">
+                          <a:solidFill>
+                            <a:srgbClr val="000000"/>
+                          </a:solidFill>
+                        </a:defRPr>
+                      </a:pPr>
+                      <a:r>
+                        <a:t>nan</a:t>
+                      </a:r>
+                    </a:p>
+                  </a:txBody>
+                  <a:tcPr>
+                    <a:solidFill>
+                      <a:srgbClr val="FFFFFF"/>
+                    </a:solidFill>
+                  </a:tcPr>
+                </a:tc>
+                <a:tc>
+                  <a:txBody>
+                    <a:bodyPr/>
+                    <a:lstStyle/>
+                    <a:p>
+                      <a:pPr>
+                        <a:defRPr sz="500" b="0">
+                          <a:solidFill>
+                            <a:srgbClr val="000000"/>
+                          </a:solidFill>
+                        </a:defRPr>
+                      </a:pPr>
+                      <a:r>
+                        <a:t>6</a:t>
+                      </a:r>
+                    </a:p>
+                  </a:txBody>
+                  <a:tcPr>
+                    <a:solidFill>
+                      <a:srgbClr val="FFFFFF"/>
+                    </a:solidFill>
+                  </a:tcPr>
+                </a:tc>
+              </a:tr>
+              <a:tr h="151600">
+                <a:tc>
+                  <a:txBody>
+                    <a:bodyPr/>
+                    <a:lstStyle/>
+                    <a:p>
+                      <a:pPr>
+                        <a:defRPr sz="500" b="0">
+                          <a:solidFill>
+                            <a:srgbClr val="000000"/>
+                          </a:solidFill>
+                        </a:defRPr>
+                      </a:pPr>
+                      <a:r>
+                        <a:t>MEASUREMENTLINKUIEDI</a:t>
+                      </a:r>
+                    </a:p>
+                  </a:txBody>
+                  <a:tcPr>
+                    <a:solidFill>
+                      <a:srgbClr val="F2F2F2"/>
+                    </a:solidFill>
+                  </a:tcPr>
+                </a:tc>
+                <a:tc>
+                  <a:txBody>
+                    <a:bodyPr/>
+                    <a:lstStyle/>
+                    <a:p>
+                      <a:pPr>
+                        <a:defRPr sz="500" b="0">
+                          <a:solidFill>
+                            <a:srgbClr val="000000"/>
+                          </a:solidFill>
+                        </a:defRPr>
+                      </a:pPr>
+                      <a:r>
+                        <a:t>2024 Q2</a:t>
+                      </a:r>
+                    </a:p>
+                  </a:txBody>
+                  <a:tcPr>
+                    <a:solidFill>
+                      <a:srgbClr val="F2F2F2"/>
+                    </a:solidFill>
+                  </a:tcPr>
+                </a:tc>
+                <a:tc>
+                  <a:txBody>
+                    <a:bodyPr/>
+                    <a:lstStyle/>
+                    <a:p>
+                      <a:pPr>
+                        <a:defRPr sz="500" b="0">
+                          <a:solidFill>
+                            <a:srgbClr val="000000"/>
+                          </a:solidFill>
+                        </a:defRPr>
+                      </a:pPr>
+                      <a:r>
+                        <a:t>5</a:t>
+                      </a:r>
+                    </a:p>
+                  </a:txBody>
+                  <a:tcPr>
+                    <a:solidFill>
+                      <a:srgbClr val="F2F2F2"/>
+                    </a:solidFill>
+                  </a:tcPr>
+                </a:tc>
+              </a:tr>
+              <a:tr h="151600">
+                <a:tc>
+                  <a:txBody>
+                    <a:bodyPr/>
+                    <a:lstStyle/>
+                    <a:p>
+                      <a:pPr>
+                        <a:defRPr sz="500" b="0">
+                          <a:solidFill>
+                            <a:srgbClr val="000000"/>
+                          </a:solidFill>
+                        </a:defRPr>
+                      </a:pPr>
+                      <a:r>
+                        <a:t>NI Compare</a:t>
+                      </a:r>
+                    </a:p>
+                  </a:txBody>
+                  <a:tcPr>
+                    <a:solidFill>
+                      <a:srgbClr val="FFFFFF"/>
+                    </a:solidFill>
+                  </a:tcPr>
+                </a:tc>
+                <a:tc>
+                  <a:txBody>
+                    <a:bodyPr/>
+                    <a:lstStyle/>
+                    <a:p>
+                      <a:pPr>
+                        <a:defRPr sz="500" b="0">
+                          <a:solidFill>
+                            <a:srgbClr val="000000"/>
+                          </a:solidFill>
+                        </a:defRPr>
+                      </a:pPr>
+                      <a:r>
+                        <a:t>5.1</a:t>
+                      </a:r>
+                    </a:p>
+                  </a:txBody>
+                  <a:tcPr>
+                    <a:solidFill>
+                      <a:srgbClr val="FFFFFF"/>
+                    </a:solidFill>
+                  </a:tcPr>
+                </a:tc>
+                <a:tc>
+                  <a:txBody>
+                    <a:bodyPr/>
+                    <a:lstStyle/>
+                    <a:p>
+                      <a:pPr>
+                        <a:defRPr sz="500" b="0">
+                          <a:solidFill>
+                            <a:srgbClr val="000000"/>
+                          </a:solidFill>
+                        </a:defRPr>
+                      </a:pPr>
+                      <a:r>
+                        <a:t>5</a:t>
+                      </a:r>
+                    </a:p>
+                  </a:txBody>
+                  <a:tcPr>
+                    <a:solidFill>
+                      <a:srgbClr val="FFFFFF"/>
+                    </a:solidFill>
+                  </a:tcPr>
+                </a:tc>
+              </a:tr>
+              <a:tr h="151600">
+                <a:tc>
+                  <a:txBody>
+                    <a:bodyPr/>
+                    <a:lstStyle/>
+                    <a:p>
+                      <a:pPr>
+                        <a:defRPr sz="500" b="0">
+                          <a:solidFill>
+                            <a:srgbClr val="000000"/>
+                          </a:solidFill>
+                        </a:defRPr>
+                      </a:pPr>
+                      <a:r>
+                        <a:t>Digital Pattern Edit</a:t>
+                      </a:r>
+                    </a:p>
+                  </a:txBody>
+                  <a:tcPr>
+                    <a:solidFill>
+                      <a:srgbClr val="F2F2F2"/>
+                    </a:solidFill>
+                  </a:tcPr>
+                </a:tc>
+                <a:tc>
+                  <a:txBody>
+                    <a:bodyPr/>
+                    <a:lstStyle/>
+                    <a:p>
+                      <a:pPr>
+                        <a:defRPr sz="500" b="0">
+                          <a:solidFill>
+                            <a:srgbClr val="000000"/>
+                          </a:solidFill>
+                        </a:defRPr>
+                      </a:pPr>
+                      <a:r>
+                        <a:t>20.6.0</a:t>
+                      </a:r>
+                    </a:p>
+                  </a:txBody>
+                  <a:tcPr>
+                    <a:solidFill>
+                      <a:srgbClr val="F2F2F2"/>
+                    </a:solidFill>
+                  </a:tcPr>
+                </a:tc>
+                <a:tc>
+                  <a:txBody>
+                    <a:bodyPr/>
+                    <a:lstStyle/>
+                    <a:p>
+                      <a:pPr>
+                        <a:defRPr sz="500" b="0">
+                          <a:solidFill>
+                            <a:srgbClr val="000000"/>
+                          </a:solidFill>
+                        </a:defRPr>
+                      </a:pPr>
+                      <a:r>
+                        <a:t>4</a:t>
+                      </a:r>
+                    </a:p>
+                  </a:txBody>
+                  <a:tcPr>
+                    <a:solidFill>
+                      <a:srgbClr val="F2F2F2"/>
+                    </a:solidFill>
+                  </a:tcPr>
+                </a:tc>
+              </a:tr>
+              <a:tr h="151600">
+                <a:tc>
+                  <a:txBody>
+                    <a:bodyPr/>
+                    <a:lstStyle/>
+                    <a:p>
+                      <a:pPr>
+                        <a:defRPr sz="500" b="0">
+                          <a:solidFill>
+                            <a:srgbClr val="000000"/>
+                          </a:solidFill>
+                        </a:defRPr>
+                      </a:pPr>
+                      <a:r>
+                        <a:t>VBAI</a:t>
+                      </a:r>
+                    </a:p>
+                  </a:txBody>
+                  <a:tcPr>
+                    <a:solidFill>
+                      <a:srgbClr val="FFFFFF"/>
+                    </a:solidFill>
+                  </a:tcPr>
+                </a:tc>
+                <a:tc>
+                  <a:txBody>
+                    <a:bodyPr/>
+                    <a:lstStyle/>
+                    <a:p>
+                      <a:pPr>
+                        <a:defRPr sz="500" b="0">
+                          <a:solidFill>
+                            <a:srgbClr val="000000"/>
+                          </a:solidFill>
+                        </a:defRPr>
+                      </a:pPr>
+                      <a:r>
+                        <a:t>19.0.0</a:t>
+                      </a:r>
+                    </a:p>
+                  </a:txBody>
+                  <a:tcPr>
+                    <a:solidFill>
+                      <a:srgbClr val="FFFFFF"/>
+                    </a:solidFill>
+                  </a:tcPr>
+                </a:tc>
+                <a:tc>
+                  <a:txBody>
+                    <a:bodyPr/>
+                    <a:lstStyle/>
+                    <a:p>
+                      <a:pPr>
+                        <a:defRPr sz="500" b="0">
+                          <a:solidFill>
+                            <a:srgbClr val="000000"/>
+                          </a:solidFill>
+                        </a:defRPr>
+                      </a:pPr>
+                      <a:r>
+                        <a:t>3</a:t>
+                      </a:r>
+                    </a:p>
+                  </a:txBody>
+                  <a:tcPr>
+                    <a:solidFill>
+                      <a:srgbClr val="FFFFFF"/>
+                    </a:solidFill>
+                  </a:tcPr>
+                </a:tc>
+              </a:tr>
+              <a:tr h="151600">
+                <a:tc>
+                  <a:txBody>
+                    <a:bodyPr/>
+                    <a:lstStyle/>
+                    <a:p>
+                      <a:pPr>
+                        <a:defRPr sz="500" b="0">
+                          <a:solidFill>
+                            <a:srgbClr val="000000"/>
+                          </a:solidFill>
+                        </a:defRPr>
+                      </a:pPr>
+                      <a:r>
+                        <a:t>MEASUREMENTLINK</a:t>
+                      </a:r>
+                    </a:p>
+                  </a:txBody>
+                  <a:tcPr>
+                    <a:solidFill>
+                      <a:srgbClr val="F2F2F2"/>
+                    </a:solidFill>
+                  </a:tcPr>
+                </a:tc>
+                <a:tc>
+                  <a:txBody>
+                    <a:bodyPr/>
+                    <a:lstStyle/>
+                    <a:p>
+                      <a:pPr>
+                        <a:defRPr sz="500" b="0">
+                          <a:solidFill>
+                            <a:srgbClr val="000000"/>
+                          </a:solidFill>
+                        </a:defRPr>
+                      </a:pPr>
+                      <a:r>
+                        <a:t>24.3.0</a:t>
+                      </a:r>
+                    </a:p>
+                  </a:txBody>
+                  <a:tcPr>
+                    <a:solidFill>
+                      <a:srgbClr val="F2F2F2"/>
+                    </a:solidFill>
+                  </a:tcPr>
+                </a:tc>
+                <a:tc>
+                  <a:txBody>
+                    <a:bodyPr/>
+                    <a:lstStyle/>
+                    <a:p>
+                      <a:pPr>
+                        <a:defRPr sz="500" b="0">
+                          <a:solidFill>
+                            <a:srgbClr val="000000"/>
+                          </a:solidFill>
+                        </a:defRPr>
+                      </a:pPr>
+                      <a:r>
+                        <a:t>2</a:t>
+                      </a:r>
+                    </a:p>
+                  </a:txBody>
+                  <a:tcPr>
+                    <a:solidFill>
+                      <a:srgbClr val="F2F2F2"/>
+                    </a:solidFill>
+                  </a:tcPr>
+                </a:tc>
+              </a:tr>
+              <a:tr h="151600">
+                <a:tc>
+                  <a:txBody>
+                    <a:bodyPr/>
+                    <a:lstStyle/>
+                    <a:p>
+                      <a:pPr>
+                        <a:defRPr sz="500" b="0">
+                          <a:solidFill>
+                            <a:srgbClr val="000000"/>
+                          </a:solidFill>
+                        </a:defRPr>
+                      </a:pPr>
+                      <a:r>
+                        <a:t>LVRT</a:t>
+                      </a:r>
+                    </a:p>
+                  </a:txBody>
+                  <a:tcPr>
+                    <a:solidFill>
+                      <a:srgbClr val="FFFFFF"/>
+                    </a:solidFill>
+                  </a:tcPr>
+                </a:tc>
+                <a:tc>
+                  <a:txBody>
+                    <a:bodyPr/>
+                    <a:lstStyle/>
+                    <a:p>
+                      <a:pPr>
+                        <a:defRPr sz="500" b="0">
+                          <a:solidFill>
+                            <a:srgbClr val="000000"/>
+                          </a:solidFill>
+                        </a:defRPr>
+                      </a:pPr>
+                      <a:r>
+                        <a:t>2017</a:t>
+                      </a:r>
+                    </a:p>
+                  </a:txBody>
+                  <a:tcPr>
+                    <a:solidFill>
+                      <a:srgbClr val="FFFFFF"/>
+                    </a:solidFill>
+                  </a:tcPr>
+                </a:tc>
+                <a:tc>
+                  <a:txBody>
+                    <a:bodyPr/>
+                    <a:lstStyle/>
+                    <a:p>
+                      <a:pPr>
+                        <a:defRPr sz="500" b="0">
+                          <a:solidFill>
+                            <a:srgbClr val="000000"/>
+                          </a:solidFill>
+                        </a:defRPr>
+                      </a:pPr>
+                      <a:r>
+                        <a:t>1</a:t>
+                      </a:r>
+                    </a:p>
+                  </a:txBody>
+                  <a:tcPr>
+                    <a:solidFill>
+                      <a:srgbClr val="FFFFFF"/>
+                    </a:solidFill>
+                  </a:tcPr>
+                </a:tc>
+              </a:tr>
+              <a:tr h="151600">
+                <a:tc>
+                  <a:txBody>
+                    <a:bodyPr/>
+                    <a:lstStyle/>
+                    <a:p>
+                      <a:pPr>
+                        <a:defRPr sz="500" b="0">
+                          <a:solidFill>
+                            <a:srgbClr val="000000"/>
+                          </a:solidFill>
+                        </a:defRPr>
+                      </a:pPr>
+                      <a:r>
+                        <a:t>SignalExpress</a:t>
+                      </a:r>
+                    </a:p>
+                  </a:txBody>
+                  <a:tcPr>
+                    <a:solidFill>
+                      <a:srgbClr val="F2F2F2"/>
+                    </a:solidFill>
+                  </a:tcPr>
+                </a:tc>
+                <a:tc>
+                  <a:txBody>
+                    <a:bodyPr/>
+                    <a:lstStyle/>
+                    <a:p>
+                      <a:pPr>
+                        <a:defRPr sz="500" b="0">
+                          <a:solidFill>
+                            <a:srgbClr val="000000"/>
+                          </a:solidFill>
+                        </a:defRPr>
+                      </a:pPr>
+                      <a:r>
+                        <a:t>15</a:t>
+                      </a:r>
+                    </a:p>
+                  </a:txBody>
+                  <a:tcPr>
+                    <a:solidFill>
+                      <a:srgbClr val="F2F2F2"/>
+                    </a:solidFill>
+                  </a:tcPr>
+                </a:tc>
+                <a:tc>
+                  <a:txBody>
+                    <a:bodyPr/>
+                    <a:lstStyle/>
+                    <a:p>
+                      <a:pPr>
+                        <a:defRPr sz="500" b="0">
+                          <a:solidFill>
+                            <a:srgbClr val="000000"/>
+                          </a:solidFill>
+                        </a:defRPr>
+                      </a:pPr>
+                      <a:r>
+                        <a:t>1</a:t>
+                      </a:r>
+                    </a:p>
+                  </a:txBody>
+                  <a:tcPr>
+                    <a:solidFill>
+                      <a:srgbClr val="F2F2F2"/>
+                    </a:solidFill>
+                  </a:tcPr>
+                </a:tc>
+              </a:tr>
+              <a:tr h="151600">
+                <a:tc>
+                  <a:txBody>
+                    <a:bodyPr/>
+                    <a:lstStyle/>
+                    <a:p>
+                      <a:pPr>
+                        <a:defRPr sz="500" b="0">
+                          <a:solidFill>
+                            <a:srgbClr val="000000"/>
+                          </a:solidFill>
+                        </a:defRPr>
+                      </a:pPr>
+                      <a:r>
+                        <a:t>RFmx SFP</a:t>
+                      </a:r>
+                    </a:p>
+                  </a:txBody>
+                  <a:tcPr>
+                    <a:solidFill>
+                      <a:srgbClr val="FFFFFF"/>
+                    </a:solidFill>
+                  </a:tcPr>
+                </a:tc>
+                <a:tc>
+                  <a:txBody>
+                    <a:bodyPr/>
+                    <a:lstStyle/>
+                    <a:p>
+                      <a:pPr>
+                        <a:defRPr sz="500" b="0">
+                          <a:solidFill>
+                            <a:srgbClr val="000000"/>
+                          </a:solidFill>
+                        </a:defRPr>
+                      </a:pPr>
+                      <a:r>
+                        <a:t>20.7.0.49199</a:t>
+                      </a:r>
+                    </a:p>
+                  </a:txBody>
+                  <a:tcPr>
+                    <a:solidFill>
+                      <a:srgbClr val="FFFFFF"/>
+                    </a:solidFill>
+                  </a:tcPr>
+                </a:tc>
+                <a:tc>
+                  <a:txBody>
+                    <a:bodyPr/>
+                    <a:lstStyle/>
+                    <a:p>
+                      <a:pPr>
+                        <a:defRPr sz="500" b="0">
+                          <a:solidFill>
+                            <a:srgbClr val="000000"/>
+                          </a:solidFill>
+                        </a:defRPr>
+                      </a:pPr>
+                      <a:r>
+                        <a:t>1</a:t>
                       </a:r>
                     </a:p>
                   </a:txBody>
@@ -5086,8 +6916,8 @@
         </p:nvSpPr>
         <p:spPr>
           <a:xfrm>
-            <a:off x="6096000" y="4494400"/>
-            <a:ext cx="2819400" cy="207000"/>
+            <a:off x="6096000" y="7276500"/>
+            <a:ext cx="2819400" cy="194300"/>
           </a:xfrm>
           <a:prstGeom prst="rect">
             <a:avLst/>
@@ -5123,8 +6953,8 @@
           <p:nvPr/>
         </p:nvGraphicFramePr>
         <p:xfrm>
-          <a:off x="6096000" y="4701400"/>
-          <a:ext cx="2819400" cy="1062000"/>
+          <a:off x="6096000" y="7470800"/>
+          <a:ext cx="2819400" cy="916750"/>
         </p:xfrm>
         <a:graphic>
           <a:graphicData uri="http://schemas.openxmlformats.org/drawingml/2006/table">
@@ -5136,14 +6966,14 @@
                 <a:gridCol w="1550670"/>
                 <a:gridCol w="1268730"/>
               </a:tblGrid>
-              <a:tr h="212400">
-                <a:tc>
-                  <a:txBody>
-                    <a:bodyPr/>
-                    <a:lstStyle/>
-                    <a:p>
-                      <a:pPr>
-                        <a:defRPr sz="800" b="1">
+              <a:tr h="183350">
+                <a:tc>
+                  <a:txBody>
+                    <a:bodyPr/>
+                    <a:lstStyle/>
+                    <a:p>
+                      <a:pPr>
+                        <a:defRPr sz="750" b="1">
                           <a:solidFill>
                             <a:srgbClr val="FFFFFF"/>
                           </a:solidFill>
@@ -5166,7 +6996,7 @@
                     <a:lstStyle/>
                     <a:p>
                       <a:pPr>
-                        <a:defRPr sz="800" b="1">
+                        <a:defRPr sz="750" b="1">
                           <a:solidFill>
                             <a:srgbClr val="FFFFFF"/>
                           </a:solidFill>
@@ -5184,21 +7014,21 @@
                   </a:tcPr>
                 </a:tc>
               </a:tr>
-              <a:tr h="212400">
-                <a:tc>
-                  <a:txBody>
-                    <a:bodyPr/>
-                    <a:lstStyle/>
-                    <a:p>
-                      <a:pPr>
-                        <a:defRPr sz="800" b="0">
-                          <a:solidFill>
-                            <a:srgbClr val="000000"/>
-                          </a:solidFill>
-                        </a:defRPr>
-                      </a:pPr>
-                      <a:r>
-                        <a:t>Total Credits</a:t>
+              <a:tr h="183350">
+                <a:tc>
+                  <a:txBody>
+                    <a:bodyPr/>
+                    <a:lstStyle/>
+                    <a:p>
+                      <a:pPr>
+                        <a:defRPr sz="750" b="0">
+                          <a:solidFill>
+                            <a:srgbClr val="000000"/>
+                          </a:solidFill>
+                        </a:defRPr>
+                      </a:pPr>
+                      <a:r>
+                        <a:t>Total</a:t>
                       </a:r>
                     </a:p>
                   </a:txBody>
@@ -5214,7 +7044,7 @@
                     <a:lstStyle/>
                     <a:p>
                       <a:pPr>
-                        <a:defRPr sz="800" b="0">
+                        <a:defRPr sz="750" b="0">
                           <a:solidFill>
                             <a:srgbClr val="000000"/>
                           </a:solidFill>
@@ -5232,14 +7062,14 @@
                   </a:tcPr>
                 </a:tc>
               </a:tr>
-              <a:tr h="212400">
-                <a:tc>
-                  <a:txBody>
-                    <a:bodyPr/>
-                    <a:lstStyle/>
-                    <a:p>
-                      <a:pPr>
-                        <a:defRPr sz="800" b="0">
+              <a:tr h="183350">
+                <a:tc>
+                  <a:txBody>
+                    <a:bodyPr/>
+                    <a:lstStyle/>
+                    <a:p>
+                      <a:pPr>
+                        <a:defRPr sz="750" b="0">
                           <a:solidFill>
                             <a:srgbClr val="000000"/>
                           </a:solidFill>
@@ -5262,7 +7092,7 @@
                     <a:lstStyle/>
                     <a:p>
                       <a:pPr>
-                        <a:defRPr sz="800" b="0">
+                        <a:defRPr sz="750" b="0">
                           <a:solidFill>
                             <a:srgbClr val="000000"/>
                           </a:solidFill>
@@ -5280,14 +7110,14 @@
                   </a:tcPr>
                 </a:tc>
               </a:tr>
-              <a:tr h="212400">
-                <a:tc>
-                  <a:txBody>
-                    <a:bodyPr/>
-                    <a:lstStyle/>
-                    <a:p>
-                      <a:pPr>
-                        <a:defRPr sz="800" b="0">
+              <a:tr h="183350">
+                <a:tc>
+                  <a:txBody>
+                    <a:bodyPr/>
+                    <a:lstStyle/>
+                    <a:p>
+                      <a:pPr>
+                        <a:defRPr sz="750" b="0">
                           <a:solidFill>
                             <a:srgbClr val="000000"/>
                           </a:solidFill>
@@ -5310,7 +7140,7 @@
                     <a:lstStyle/>
                     <a:p>
                       <a:pPr>
-                        <a:defRPr sz="800" b="0">
+                        <a:defRPr sz="750" b="0">
                           <a:solidFill>
                             <a:srgbClr val="000000"/>
                           </a:solidFill>
@@ -5328,14 +7158,14 @@
                   </a:tcPr>
                 </a:tc>
               </a:tr>
-              <a:tr h="212400">
-                <a:tc>
-                  <a:txBody>
-                    <a:bodyPr/>
-                    <a:lstStyle/>
-                    <a:p>
-                      <a:pPr>
-                        <a:defRPr sz="800" b="0">
+              <a:tr h="183350">
+                <a:tc>
+                  <a:txBody>
+                    <a:bodyPr/>
+                    <a:lstStyle/>
+                    <a:p>
+                      <a:pPr>
+                        <a:defRPr sz="750" b="0">
                           <a:solidFill>
                             <a:srgbClr val="000000"/>
                           </a:solidFill>
@@ -5358,7 +7188,7 @@
                     <a:lstStyle/>
                     <a:p>
                       <a:pPr>
-                        <a:defRPr sz="800" b="0">
+                        <a:defRPr sz="750" b="0">
                           <a:solidFill>
                             <a:srgbClr val="000000"/>
                           </a:solidFill>
@@ -5388,8 +7218,8 @@
         </p:nvSpPr>
         <p:spPr>
           <a:xfrm>
-            <a:off x="6096000" y="5843400"/>
-            <a:ext cx="2819400" cy="207000"/>
+            <a:off x="6096000" y="8501850"/>
+            <a:ext cx="2819400" cy="194300"/>
           </a:xfrm>
           <a:prstGeom prst="rect">
             <a:avLst/>
@@ -5425,8 +7255,8 @@
           <p:nvPr/>
         </p:nvGraphicFramePr>
         <p:xfrm>
-          <a:off x="6096000" y="6050400"/>
-          <a:ext cx="2819400" cy="424800"/>
+          <a:off x="6096000" y="8696150"/>
+          <a:ext cx="2819400" cy="366700"/>
         </p:xfrm>
         <a:graphic>
           <a:graphicData uri="http://schemas.openxmlformats.org/drawingml/2006/table">
@@ -5437,14 +7267,14 @@
               <a:tblGrid>
                 <a:gridCol w="2819400"/>
               </a:tblGrid>
-              <a:tr h="212400">
-                <a:tc>
-                  <a:txBody>
-                    <a:bodyPr/>
-                    <a:lstStyle/>
-                    <a:p>
-                      <a:pPr>
-                        <a:defRPr sz="800" b="1">
+              <a:tr h="183350">
+                <a:tc>
+                  <a:txBody>
+                    <a:bodyPr/>
+                    <a:lstStyle/>
+                    <a:p>
+                      <a:pPr>
+                        <a:defRPr sz="750" b="1">
                           <a:solidFill>
                             <a:srgbClr val="FFFFFF"/>
                           </a:solidFill>
@@ -5462,14 +7292,14 @@
                   </a:tcPr>
                 </a:tc>
               </a:tr>
-              <a:tr h="212400">
-                <a:tc>
-                  <a:txBody>
-                    <a:bodyPr/>
-                    <a:lstStyle/>
-                    <a:p>
-                      <a:pPr>
-                        <a:defRPr sz="800" b="0">
+              <a:tr h="183350">
+                <a:tc>
+                  <a:txBody>
+                    <a:bodyPr/>
+                    <a:lstStyle/>
+                    <a:p>
+                      <a:pPr>
+                        <a:defRPr sz="750" b="0">
                           <a:solidFill>
                             <a:srgbClr val="000000"/>
                           </a:solidFill>

</xml_diff>